<commit_message>
Sync the three project repos in place of the fixtures
Co-Authored-By: Claude Opus 5.5 <noreply@anthropic.com>
Claude-Session: https://claude.ai/code/session_01QhAcegZCA84C1dHz9XeXfw
</commit_message>
<xml_diff>
--- a/public/projects/architecture-three-ways/slides/01-layers/engineer.pptx
+++ b/public/projects/architecture-three-ways/slides/01-layers/engineer.pptx
@@ -857,7 +857,7 @@
     <p:bg>
       <p:bgPr>
         <a:solidFill>
-          <a:srgbClr val="E2EBF4"/>
+          <a:srgbClr val="FFFFFF"/>
         </a:solidFill>
       </p:bgPr>
     </p:bg>
@@ -877,14 +877,14 @@
       </p:grpSpPr>
       <p:sp>
         <p:nvSpPr>
-          <p:cNvPr id="2" name="Text 0"/>
-          <p:cNvSpPr/>
-          <p:nvPr/>
-        </p:nvSpPr>
-        <p:spPr>
-          <a:xfrm>
-            <a:off x="457200" y="2194560"/>
-            <a:ext cx="11274552" cy="1280160"/>
+          <p:cNvPr id="2" name="Title"/>
+          <p:cNvSpPr/>
+          <p:nvPr/>
+        </p:nvSpPr>
+        <p:spPr>
+          <a:xfrm>
+            <a:off x="457200" y="457200"/>
+            <a:ext cx="11274552" cy="841248"/>
           </a:xfrm>
           <a:prstGeom prst="rect">
             <a:avLst/>
@@ -893,37 +893,40 @@
           <a:ln/>
         </p:spPr>
         <p:txBody>
-          <a:bodyPr wrap="square" rtlCol="0" anchor="ctr"/>
-          <a:lstStyle/>
-          <a:p>
-            <a:pPr algn="ctr" indent="0" marL="0">
-              <a:buNone/>
-            </a:pPr>
-            <a:r>
-              <a:rPr lang="en-US" sz="6600" b="1" dirty="0">
-                <a:solidFill>
-                  <a:srgbClr val="1F3B57"/>
-                </a:solidFill>
-                <a:latin typeface="Arial" pitchFamily="34" charset="0"/>
-                <a:ea typeface="Arial" pitchFamily="34" charset="-122"/>
-                <a:cs typeface="Arial" pitchFamily="34" charset="-120"/>
-              </a:rPr>
-              <a:t>PLACEHOLDER</a:t>
-            </a:r>
-            <a:endParaRPr lang="en-US" sz="6600" dirty="0"/>
-          </a:p>
-        </p:txBody>
-      </p:sp>
-      <p:sp>
-        <p:nvSpPr>
-          <p:cNvPr id="3" name="Text 1"/>
-          <p:cNvSpPr/>
-          <p:nvPr/>
-        </p:nvSpPr>
-        <p:spPr>
-          <a:xfrm>
-            <a:off x="457200" y="3657600"/>
-            <a:ext cx="11274552" cy="548640"/>
+          <a:bodyPr wrap="square" lIns="0" tIns="0" rIns="0" bIns="0" rtlCol="0" anchor="t"/>
+          <a:lstStyle/>
+          <a:p>
+            <a:pPr algn="l" indent="0" marL="0">
+              <a:lnSpc>
+                <a:spcPct val="95000"/>
+              </a:lnSpc>
+              <a:buNone/>
+            </a:pPr>
+            <a:r>
+              <a:rPr lang="en-US" sz="2800" b="1" dirty="0">
+                <a:solidFill>
+                  <a:srgbClr val="1F2328"/>
+                </a:solidFill>
+                <a:latin typeface="Arial" pitchFamily="34" charset="0"/>
+                <a:ea typeface="Arial" pitchFamily="34" charset="-122"/>
+                <a:cs typeface="Arial" pitchFamily="34" charset="-120"/>
+              </a:rPr>
+              <a:t>The OSAL and PSP hide the real-time OS and the board, so the cFE and the apps above it stay platform independent</a:t>
+            </a:r>
+            <a:endParaRPr lang="en-US" sz="2800" dirty="0"/>
+          </a:p>
+        </p:txBody>
+      </p:sp>
+      <p:sp>
+        <p:nvSpPr>
+          <p:cNvPr id="3" name="Layer name A"/>
+          <p:cNvSpPr/>
+          <p:nvPr/>
+        </p:nvSpPr>
+        <p:spPr>
+          <a:xfrm>
+            <a:off x="457200" y="1481328"/>
+            <a:ext cx="1005840" cy="786384"/>
           </a:xfrm>
           <a:prstGeom prst="rect">
             <a:avLst/>
@@ -932,24 +935,2987 @@
           <a:ln/>
         </p:spPr>
         <p:txBody>
-          <a:bodyPr wrap="square" rtlCol="0" anchor="ctr"/>
+          <a:bodyPr wrap="square" lIns="0" tIns="0" rIns="0" bIns="0" rtlCol="0" anchor="ctr"/>
+          <a:lstStyle/>
+          <a:p>
+            <a:pPr algn="l" indent="0" marL="0">
+              <a:buNone/>
+            </a:pPr>
+            <a:r>
+              <a:rPr lang="en-US" sz="1100" b="1" dirty="0">
+                <a:solidFill>
+                  <a:srgbClr val="565E69"/>
+                </a:solidFill>
+                <a:latin typeface="Arial" pitchFamily="34" charset="0"/>
+                <a:ea typeface="Arial" pitchFamily="34" charset="-122"/>
+                <a:cs typeface="Arial" pitchFamily="34" charset="-120"/>
+              </a:rPr>
+              <a:t>Application layer</a:t>
+            </a:r>
+            <a:endParaRPr lang="en-US" sz="1100" dirty="0"/>
+          </a:p>
+        </p:txBody>
+      </p:sp>
+      <p:sp>
+        <p:nvSpPr>
+          <p:cNvPr id="4" name="Layer name B"/>
+          <p:cNvSpPr/>
+          <p:nvPr/>
+        </p:nvSpPr>
+        <p:spPr>
+          <a:xfrm>
+            <a:off x="457200" y="2340864"/>
+            <a:ext cx="1005840" cy="493776"/>
+          </a:xfrm>
+          <a:prstGeom prst="rect">
+            <a:avLst/>
+          </a:prstGeom>
+          <a:noFill/>
+          <a:ln/>
+        </p:spPr>
+        <p:txBody>
+          <a:bodyPr wrap="square" lIns="0" tIns="0" rIns="0" bIns="0" rtlCol="0" anchor="ctr"/>
+          <a:lstStyle/>
+          <a:p>
+            <a:pPr algn="l" indent="0" marL="0">
+              <a:buNone/>
+            </a:pPr>
+            <a:r>
+              <a:rPr lang="en-US" sz="1100" b="1" dirty="0">
+                <a:solidFill>
+                  <a:srgbClr val="565E69"/>
+                </a:solidFill>
+                <a:latin typeface="Arial" pitchFamily="34" charset="0"/>
+                <a:ea typeface="Arial" pitchFamily="34" charset="-122"/>
+                <a:cs typeface="Arial" pitchFamily="34" charset="-120"/>
+              </a:rPr>
+              <a:t>Library layer</a:t>
+            </a:r>
+            <a:endParaRPr lang="en-US" sz="1100" dirty="0"/>
+          </a:p>
+        </p:txBody>
+      </p:sp>
+      <p:sp>
+        <p:nvSpPr>
+          <p:cNvPr id="5" name="Layer name C"/>
+          <p:cNvSpPr/>
+          <p:nvPr/>
+        </p:nvSpPr>
+        <p:spPr>
+          <a:xfrm>
+            <a:off x="457200" y="2907792"/>
+            <a:ext cx="1005840" cy="1060704"/>
+          </a:xfrm>
+          <a:prstGeom prst="rect">
+            <a:avLst/>
+          </a:prstGeom>
+          <a:noFill/>
+          <a:ln/>
+        </p:spPr>
+        <p:txBody>
+          <a:bodyPr wrap="square" lIns="0" tIns="0" rIns="0" bIns="0" rtlCol="0" anchor="ctr"/>
+          <a:lstStyle/>
+          <a:p>
+            <a:pPr algn="l" indent="0" marL="0">
+              <a:buNone/>
+            </a:pPr>
+            <a:r>
+              <a:rPr lang="en-US" sz="1100" b="1" dirty="0">
+                <a:solidFill>
+                  <a:srgbClr val="565E69"/>
+                </a:solidFill>
+                <a:latin typeface="Arial" pitchFamily="34" charset="0"/>
+                <a:ea typeface="Arial" pitchFamily="34" charset="-122"/>
+                <a:cs typeface="Arial" pitchFamily="34" charset="-120"/>
+              </a:rPr>
+              <a:t>cFE core layer</a:t>
+            </a:r>
+            <a:endParaRPr lang="en-US" sz="1100" dirty="0"/>
+          </a:p>
+        </p:txBody>
+      </p:sp>
+      <p:sp>
+        <p:nvSpPr>
+          <p:cNvPr id="6" name="Layer name D"/>
+          <p:cNvSpPr/>
+          <p:nvPr/>
+        </p:nvSpPr>
+        <p:spPr>
+          <a:xfrm>
+            <a:off x="457200" y="4041648"/>
+            <a:ext cx="1005840" cy="896112"/>
+          </a:xfrm>
+          <a:prstGeom prst="rect">
+            <a:avLst/>
+          </a:prstGeom>
+          <a:noFill/>
+          <a:ln/>
+        </p:spPr>
+        <p:txBody>
+          <a:bodyPr wrap="square" lIns="0" tIns="0" rIns="0" bIns="0" rtlCol="0" anchor="ctr"/>
+          <a:lstStyle/>
+          <a:p>
+            <a:pPr algn="l" indent="0" marL="0">
+              <a:buNone/>
+            </a:pPr>
+            <a:r>
+              <a:rPr lang="en-US" sz="1100" b="1" dirty="0">
+                <a:solidFill>
+                  <a:srgbClr val="565E69"/>
+                </a:solidFill>
+                <a:latin typeface="Arial" pitchFamily="34" charset="0"/>
+                <a:ea typeface="Arial" pitchFamily="34" charset="-122"/>
+                <a:cs typeface="Arial" pitchFamily="34" charset="-120"/>
+              </a:rPr>
+              <a:t>Abstraction library layer</a:t>
+            </a:r>
+            <a:endParaRPr lang="en-US" sz="1100" dirty="0"/>
+          </a:p>
+        </p:txBody>
+      </p:sp>
+      <p:sp>
+        <p:nvSpPr>
+          <p:cNvPr id="7" name="Layer name E"/>
+          <p:cNvSpPr/>
+          <p:nvPr/>
+        </p:nvSpPr>
+        <p:spPr>
+          <a:xfrm>
+            <a:off x="457200" y="5010912"/>
+            <a:ext cx="1005840" cy="548640"/>
+          </a:xfrm>
+          <a:prstGeom prst="rect">
+            <a:avLst/>
+          </a:prstGeom>
+          <a:noFill/>
+          <a:ln/>
+        </p:spPr>
+        <p:txBody>
+          <a:bodyPr wrap="square" lIns="0" tIns="0" rIns="0" bIns="0" rtlCol="0" anchor="ctr"/>
+          <a:lstStyle/>
+          <a:p>
+            <a:pPr algn="l" indent="0" marL="0">
+              <a:buNone/>
+            </a:pPr>
+            <a:r>
+              <a:rPr lang="en-US" sz="1100" b="1" dirty="0">
+                <a:solidFill>
+                  <a:srgbClr val="565E69"/>
+                </a:solidFill>
+                <a:latin typeface="Arial" pitchFamily="34" charset="0"/>
+                <a:ea typeface="Arial" pitchFamily="34" charset="-122"/>
+                <a:cs typeface="Arial" pitchFamily="34" charset="-120"/>
+              </a:rPr>
+              <a:t>RTOS and boot layer</a:t>
+            </a:r>
+            <a:endParaRPr lang="en-US" sz="1100" dirty="0"/>
+          </a:p>
+        </p:txBody>
+      </p:sp>
+      <p:sp>
+        <p:nvSpPr>
+          <p:cNvPr id="8" name="Layer rule B"/>
+          <p:cNvSpPr/>
+          <p:nvPr/>
+        </p:nvSpPr>
+        <p:spPr>
+          <a:xfrm>
+            <a:off x="457200" y="2304288"/>
+            <a:ext cx="7223760" cy="0"/>
+          </a:xfrm>
+          <a:prstGeom prst="line">
+            <a:avLst/>
+          </a:prstGeom>
+          <a:noFill/>
+          <a:ln w="12700">
+            <a:solidFill>
+              <a:srgbClr val="C7CDD4"/>
+            </a:solidFill>
+            <a:prstDash val="dash"/>
+          </a:ln>
+        </p:spPr>
+      </p:sp>
+      <p:sp>
+        <p:nvSpPr>
+          <p:cNvPr id="9" name="Layer rule C"/>
+          <p:cNvSpPr/>
+          <p:nvPr/>
+        </p:nvSpPr>
+        <p:spPr>
+          <a:xfrm>
+            <a:off x="457200" y="2871216"/>
+            <a:ext cx="7223760" cy="0"/>
+          </a:xfrm>
+          <a:prstGeom prst="line">
+            <a:avLst/>
+          </a:prstGeom>
+          <a:noFill/>
+          <a:ln w="12700">
+            <a:solidFill>
+              <a:srgbClr val="C7CDD4"/>
+            </a:solidFill>
+            <a:prstDash val="dash"/>
+          </a:ln>
+        </p:spPr>
+      </p:sp>
+      <p:sp>
+        <p:nvSpPr>
+          <p:cNvPr id="10" name="Layer rule D"/>
+          <p:cNvSpPr/>
+          <p:nvPr/>
+        </p:nvSpPr>
+        <p:spPr>
+          <a:xfrm>
+            <a:off x="457200" y="4005072"/>
+            <a:ext cx="7223760" cy="0"/>
+          </a:xfrm>
+          <a:prstGeom prst="line">
+            <a:avLst/>
+          </a:prstGeom>
+          <a:noFill/>
+          <a:ln w="12700">
+            <a:solidFill>
+              <a:srgbClr val="C7CDD4"/>
+            </a:solidFill>
+            <a:prstDash val="dash"/>
+          </a:ln>
+        </p:spPr>
+      </p:sp>
+      <p:sp>
+        <p:nvSpPr>
+          <p:cNvPr id="11" name="Layer rule E"/>
+          <p:cNvSpPr/>
+          <p:nvPr/>
+        </p:nvSpPr>
+        <p:spPr>
+          <a:xfrm>
+            <a:off x="457200" y="4974336"/>
+            <a:ext cx="7223760" cy="0"/>
+          </a:xfrm>
+          <a:prstGeom prst="line">
+            <a:avLst/>
+          </a:prstGeom>
+          <a:noFill/>
+          <a:ln w="12700">
+            <a:solidFill>
+              <a:srgbClr val="C7CDD4"/>
+            </a:solidFill>
+            <a:prstDash val="dash"/>
+          </a:ln>
+        </p:spPr>
+      </p:sp>
+      <p:sp>
+        <p:nvSpPr>
+          <p:cNvPr id="12" name="cFE Apps stack back"/>
+          <p:cNvSpPr/>
+          <p:nvPr/>
+        </p:nvSpPr>
+        <p:spPr>
+          <a:xfrm>
+            <a:off x="1664208" y="1536192"/>
+            <a:ext cx="640080" cy="566928"/>
+          </a:xfrm>
+          <a:prstGeom prst="roundRect">
+            <a:avLst>
+              <a:gd name="adj" fmla="val 12903"/>
+            </a:avLst>
+          </a:prstGeom>
+          <a:solidFill>
+            <a:srgbClr val="DCE6F0"/>
+          </a:solidFill>
+          <a:ln w="12700">
+            <a:solidFill>
+              <a:srgbClr val="2F5D8A"/>
+            </a:solidFill>
+            <a:prstDash val="solid"/>
+          </a:ln>
+        </p:spPr>
+      </p:sp>
+      <p:sp>
+        <p:nvSpPr>
+          <p:cNvPr id="13" name="cFE Apps stack middle"/>
+          <p:cNvSpPr/>
+          <p:nvPr/>
+        </p:nvSpPr>
+        <p:spPr>
+          <a:xfrm>
+            <a:off x="1618488" y="1563624"/>
+            <a:ext cx="640080" cy="566928"/>
+          </a:xfrm>
+          <a:prstGeom prst="roundRect">
+            <a:avLst>
+              <a:gd name="adj" fmla="val 12903"/>
+            </a:avLst>
+          </a:prstGeom>
+          <a:solidFill>
+            <a:srgbClr val="DCE6F0"/>
+          </a:solidFill>
+          <a:ln w="12700">
+            <a:solidFill>
+              <a:srgbClr val="2F5D8A"/>
+            </a:solidFill>
+            <a:prstDash val="solid"/>
+          </a:ln>
+        </p:spPr>
+      </p:sp>
+      <p:sp>
+        <p:nvSpPr>
+          <p:cNvPr id="14" name="cFE Apps (x5)"/>
+          <p:cNvSpPr/>
+          <p:nvPr/>
+        </p:nvSpPr>
+        <p:spPr>
+          <a:xfrm>
+            <a:off x="1572768" y="1591056"/>
+            <a:ext cx="640080" cy="566928"/>
+          </a:xfrm>
+          <a:prstGeom prst="roundRect">
+            <a:avLst>
+              <a:gd name="adj" fmla="val 12903"/>
+            </a:avLst>
+          </a:prstGeom>
+          <a:solidFill>
+            <a:srgbClr val="DCE6F0"/>
+          </a:solidFill>
+          <a:ln w="12700">
+            <a:solidFill>
+              <a:srgbClr val="2F5D8A"/>
+            </a:solidFill>
+            <a:prstDash val="solid"/>
+          </a:ln>
+        </p:spPr>
+        <p:txBody>
+          <a:bodyPr wrap="square" lIns="38100" tIns="25400" rIns="38100" bIns="25400" rtlCol="0" anchor="ctr"/>
           <a:lstStyle/>
           <a:p>
             <a:pPr algn="ctr" indent="0" marL="0">
               <a:buNone/>
             </a:pPr>
             <a:r>
-              <a:rPr lang="en-US" sz="1800" dirty="0">
-                <a:solidFill>
-                  <a:srgbClr val="1F3B57"/>
-                </a:solidFill>
-                <a:latin typeface="Arial" pitchFamily="34" charset="0"/>
-                <a:ea typeface="Arial" pitchFamily="34" charset="-122"/>
-                <a:cs typeface="Arial" pitchFamily="34" charset="-120"/>
-              </a:rPr>
-              <a:t>architecture-three-ways/slides/01-layers/engineer.pptx</a:t>
-            </a:r>
-            <a:endParaRPr lang="en-US" sz="1800" dirty="0"/>
+              <a:rPr lang="en-US" sz="1100" dirty="0">
+                <a:solidFill>
+                  <a:srgbClr val="1F2328"/>
+                </a:solidFill>
+                <a:latin typeface="Arial" pitchFamily="34" charset="0"/>
+                <a:ea typeface="Arial" pitchFamily="34" charset="-122"/>
+                <a:cs typeface="Arial" pitchFamily="34" charset="-120"/>
+              </a:rPr>
+              <a:t>cFE Apps (x5)</a:t>
+            </a:r>
+            <a:endParaRPr lang="en-US" sz="1100" dirty="0"/>
+          </a:p>
+        </p:txBody>
+      </p:sp>
+      <p:sp>
+        <p:nvSpPr>
+          <p:cNvPr id="15" name="Software Bus Network"/>
+          <p:cNvSpPr/>
+          <p:nvPr/>
+        </p:nvSpPr>
+        <p:spPr>
+          <a:xfrm>
+            <a:off x="2414016" y="1591056"/>
+            <a:ext cx="749808" cy="566928"/>
+          </a:xfrm>
+          <a:prstGeom prst="roundRect">
+            <a:avLst>
+              <a:gd name="adj" fmla="val 12903"/>
+            </a:avLst>
+          </a:prstGeom>
+          <a:solidFill>
+            <a:srgbClr val="FFFFFF"/>
+          </a:solidFill>
+          <a:ln w="15875">
+            <a:solidFill>
+              <a:srgbClr val="2F5D8A"/>
+            </a:solidFill>
+            <a:prstDash val="dash"/>
+          </a:ln>
+        </p:spPr>
+        <p:txBody>
+          <a:bodyPr wrap="square" lIns="38100" tIns="25400" rIns="38100" bIns="25400" rtlCol="0" anchor="ctr"/>
+          <a:lstStyle/>
+          <a:p>
+            <a:pPr algn="ctr" indent="0" marL="0">
+              <a:buNone/>
+            </a:pPr>
+            <a:r>
+              <a:rPr lang="en-US" sz="1100" dirty="0">
+                <a:solidFill>
+                  <a:srgbClr val="1F2328"/>
+                </a:solidFill>
+                <a:latin typeface="Arial" pitchFamily="34" charset="0"/>
+                <a:ea typeface="Arial" pitchFamily="34" charset="-122"/>
+                <a:cs typeface="Arial" pitchFamily="34" charset="-120"/>
+              </a:rPr>
+              <a:t>Software Bus Network</a:t>
+            </a:r>
+            <a:endParaRPr lang="en-US" sz="1100" dirty="0"/>
+          </a:p>
+        </p:txBody>
+      </p:sp>
+      <p:sp>
+        <p:nvSpPr>
+          <p:cNvPr id="16" name="cFS App 1"/>
+          <p:cNvSpPr/>
+          <p:nvPr/>
+        </p:nvSpPr>
+        <p:spPr>
+          <a:xfrm>
+            <a:off x="3273552" y="1591056"/>
+            <a:ext cx="640080" cy="566928"/>
+          </a:xfrm>
+          <a:prstGeom prst="roundRect">
+            <a:avLst>
+              <a:gd name="adj" fmla="val 12903"/>
+            </a:avLst>
+          </a:prstGeom>
+          <a:solidFill>
+            <a:srgbClr val="DCE6F0"/>
+          </a:solidFill>
+          <a:ln w="12700">
+            <a:solidFill>
+              <a:srgbClr val="2F5D8A"/>
+            </a:solidFill>
+            <a:prstDash val="solid"/>
+          </a:ln>
+        </p:spPr>
+        <p:txBody>
+          <a:bodyPr wrap="square" lIns="38100" tIns="25400" rIns="38100" bIns="25400" rtlCol="0" anchor="ctr"/>
+          <a:lstStyle/>
+          <a:p>
+            <a:pPr algn="ctr" indent="0" marL="0">
+              <a:buNone/>
+            </a:pPr>
+            <a:r>
+              <a:rPr lang="en-US" sz="1100" dirty="0">
+                <a:solidFill>
+                  <a:srgbClr val="1F2328"/>
+                </a:solidFill>
+                <a:latin typeface="Arial" pitchFamily="34" charset="0"/>
+                <a:ea typeface="Arial" pitchFamily="34" charset="-122"/>
+                <a:cs typeface="Arial" pitchFamily="34" charset="-120"/>
+              </a:rPr>
+              <a:t>cFS App 1</a:t>
+            </a:r>
+            <a:endParaRPr lang="en-US" sz="1100" dirty="0"/>
+          </a:p>
+        </p:txBody>
+      </p:sp>
+      <p:sp>
+        <p:nvSpPr>
+          <p:cNvPr id="17" name="More cFS apps"/>
+          <p:cNvSpPr/>
+          <p:nvPr/>
+        </p:nvSpPr>
+        <p:spPr>
+          <a:xfrm>
+            <a:off x="3950208" y="1591056"/>
+            <a:ext cx="310896" cy="566928"/>
+          </a:xfrm>
+          <a:prstGeom prst="rect">
+            <a:avLst/>
+          </a:prstGeom>
+          <a:noFill/>
+          <a:ln/>
+        </p:spPr>
+        <p:txBody>
+          <a:bodyPr wrap="square" lIns="0" tIns="0" rIns="0" bIns="0" rtlCol="0" anchor="ctr"/>
+          <a:lstStyle/>
+          <a:p>
+            <a:pPr algn="ctr" indent="0" marL="0">
+              <a:buNone/>
+            </a:pPr>
+            <a:r>
+              <a:rPr lang="en-US" sz="1200" dirty="0">
+                <a:solidFill>
+                  <a:srgbClr val="565E69"/>
+                </a:solidFill>
+                <a:latin typeface="Arial" pitchFamily="34" charset="0"/>
+                <a:ea typeface="Arial" pitchFamily="34" charset="-122"/>
+                <a:cs typeface="Arial" pitchFamily="34" charset="-120"/>
+              </a:rPr>
+              <a:t>•••</a:t>
+            </a:r>
+            <a:endParaRPr lang="en-US" sz="1200" dirty="0"/>
+          </a:p>
+        </p:txBody>
+      </p:sp>
+      <p:sp>
+        <p:nvSpPr>
+          <p:cNvPr id="18" name="cFS App n(13)"/>
+          <p:cNvSpPr/>
+          <p:nvPr/>
+        </p:nvSpPr>
+        <p:spPr>
+          <a:xfrm>
+            <a:off x="4297680" y="1591056"/>
+            <a:ext cx="640080" cy="566928"/>
+          </a:xfrm>
+          <a:prstGeom prst="roundRect">
+            <a:avLst>
+              <a:gd name="adj" fmla="val 12903"/>
+            </a:avLst>
+          </a:prstGeom>
+          <a:solidFill>
+            <a:srgbClr val="DCE6F0"/>
+          </a:solidFill>
+          <a:ln w="12700">
+            <a:solidFill>
+              <a:srgbClr val="2F5D8A"/>
+            </a:solidFill>
+            <a:prstDash val="solid"/>
+          </a:ln>
+        </p:spPr>
+        <p:txBody>
+          <a:bodyPr wrap="square" lIns="38100" tIns="25400" rIns="38100" bIns="25400" rtlCol="0" anchor="ctr"/>
+          <a:lstStyle/>
+          <a:p>
+            <a:pPr algn="ctr" indent="0" marL="0">
+              <a:buNone/>
+            </a:pPr>
+            <a:r>
+              <a:rPr lang="en-US" sz="1100" dirty="0">
+                <a:solidFill>
+                  <a:srgbClr val="1F2328"/>
+                </a:solidFill>
+                <a:latin typeface="Arial" pitchFamily="34" charset="0"/>
+                <a:ea typeface="Arial" pitchFamily="34" charset="-122"/>
+                <a:cs typeface="Arial" pitchFamily="34" charset="-120"/>
+              </a:rPr>
+              <a:t>cFS App n(13)</a:t>
+            </a:r>
+            <a:endParaRPr lang="en-US" sz="1100" dirty="0"/>
+          </a:p>
+        </p:txBody>
+      </p:sp>
+      <p:sp>
+        <p:nvSpPr>
+          <p:cNvPr id="19" name="Mission App 1"/>
+          <p:cNvSpPr/>
+          <p:nvPr/>
+        </p:nvSpPr>
+        <p:spPr>
+          <a:xfrm>
+            <a:off x="5047488" y="1591056"/>
+            <a:ext cx="713232" cy="566928"/>
+          </a:xfrm>
+          <a:prstGeom prst="roundRect">
+            <a:avLst>
+              <a:gd name="adj" fmla="val 12903"/>
+            </a:avLst>
+          </a:prstGeom>
+          <a:solidFill>
+            <a:srgbClr val="FBE4D2"/>
+          </a:solidFill>
+          <a:ln w="15875">
+            <a:solidFill>
+              <a:srgbClr val="B85F1E"/>
+            </a:solidFill>
+            <a:prstDash val="solid"/>
+          </a:ln>
+        </p:spPr>
+        <p:txBody>
+          <a:bodyPr wrap="square" lIns="38100" tIns="25400" rIns="38100" bIns="25400" rtlCol="0" anchor="ctr"/>
+          <a:lstStyle/>
+          <a:p>
+            <a:pPr algn="ctr" indent="0" marL="0">
+              <a:buNone/>
+            </a:pPr>
+            <a:r>
+              <a:rPr lang="en-US" sz="1100" dirty="0">
+                <a:solidFill>
+                  <a:srgbClr val="1F2328"/>
+                </a:solidFill>
+                <a:latin typeface="Arial" pitchFamily="34" charset="0"/>
+                <a:ea typeface="Arial" pitchFamily="34" charset="-122"/>
+                <a:cs typeface="Arial" pitchFamily="34" charset="-120"/>
+              </a:rPr>
+              <a:t>Mission App 1</a:t>
+            </a:r>
+            <a:endParaRPr lang="en-US" sz="1100" dirty="0"/>
+          </a:p>
+        </p:txBody>
+      </p:sp>
+      <p:sp>
+        <p:nvSpPr>
+          <p:cNvPr id="20" name="Mission App 2"/>
+          <p:cNvSpPr/>
+          <p:nvPr/>
+        </p:nvSpPr>
+        <p:spPr>
+          <a:xfrm>
+            <a:off x="5852160" y="1591056"/>
+            <a:ext cx="713232" cy="566928"/>
+          </a:xfrm>
+          <a:prstGeom prst="roundRect">
+            <a:avLst>
+              <a:gd name="adj" fmla="val 12903"/>
+            </a:avLst>
+          </a:prstGeom>
+          <a:solidFill>
+            <a:srgbClr val="FBE4D2"/>
+          </a:solidFill>
+          <a:ln w="15875">
+            <a:solidFill>
+              <a:srgbClr val="B85F1E"/>
+            </a:solidFill>
+            <a:prstDash val="solid"/>
+          </a:ln>
+        </p:spPr>
+        <p:txBody>
+          <a:bodyPr wrap="square" lIns="38100" tIns="25400" rIns="38100" bIns="25400" rtlCol="0" anchor="ctr"/>
+          <a:lstStyle/>
+          <a:p>
+            <a:pPr algn="ctr" indent="0" marL="0">
+              <a:buNone/>
+            </a:pPr>
+            <a:r>
+              <a:rPr lang="en-US" sz="1100" dirty="0">
+                <a:solidFill>
+                  <a:srgbClr val="1F2328"/>
+                </a:solidFill>
+                <a:latin typeface="Arial" pitchFamily="34" charset="0"/>
+                <a:ea typeface="Arial" pitchFamily="34" charset="-122"/>
+                <a:cs typeface="Arial" pitchFamily="34" charset="-120"/>
+              </a:rPr>
+              <a:t>Mission App 2</a:t>
+            </a:r>
+            <a:endParaRPr lang="en-US" sz="1100" dirty="0"/>
+          </a:p>
+        </p:txBody>
+      </p:sp>
+      <p:sp>
+        <p:nvSpPr>
+          <p:cNvPr id="21" name="Mission App N"/>
+          <p:cNvSpPr/>
+          <p:nvPr/>
+        </p:nvSpPr>
+        <p:spPr>
+          <a:xfrm>
+            <a:off x="6656832" y="1591056"/>
+            <a:ext cx="713232" cy="566928"/>
+          </a:xfrm>
+          <a:prstGeom prst="roundRect">
+            <a:avLst>
+              <a:gd name="adj" fmla="val 12903"/>
+            </a:avLst>
+          </a:prstGeom>
+          <a:solidFill>
+            <a:srgbClr val="FBE4D2"/>
+          </a:solidFill>
+          <a:ln w="15875">
+            <a:solidFill>
+              <a:srgbClr val="B85F1E"/>
+            </a:solidFill>
+            <a:prstDash val="solid"/>
+          </a:ln>
+        </p:spPr>
+        <p:txBody>
+          <a:bodyPr wrap="square" lIns="38100" tIns="25400" rIns="38100" bIns="25400" rtlCol="0" anchor="ctr"/>
+          <a:lstStyle/>
+          <a:p>
+            <a:pPr algn="ctr" indent="0" marL="0">
+              <a:buNone/>
+            </a:pPr>
+            <a:r>
+              <a:rPr lang="en-US" sz="1100" dirty="0">
+                <a:solidFill>
+                  <a:srgbClr val="1F2328"/>
+                </a:solidFill>
+                <a:latin typeface="Arial" pitchFamily="34" charset="0"/>
+                <a:ea typeface="Arial" pitchFamily="34" charset="-122"/>
+                <a:cs typeface="Arial" pitchFamily="34" charset="-120"/>
+              </a:rPr>
+              <a:t>Mission App N</a:t>
+            </a:r>
+            <a:endParaRPr lang="en-US" sz="1100" dirty="0"/>
+          </a:p>
+        </p:txBody>
+      </p:sp>
+      <p:sp>
+        <p:nvSpPr>
+          <p:cNvPr id="22" name="cFS Library"/>
+          <p:cNvSpPr/>
+          <p:nvPr/>
+        </p:nvSpPr>
+        <p:spPr>
+          <a:xfrm>
+            <a:off x="1572768" y="2404872"/>
+            <a:ext cx="1188720" cy="365760"/>
+          </a:xfrm>
+          <a:prstGeom prst="rect">
+            <a:avLst/>
+          </a:prstGeom>
+          <a:solidFill>
+            <a:srgbClr val="DCE6F0"/>
+          </a:solidFill>
+          <a:ln w="12700">
+            <a:solidFill>
+              <a:srgbClr val="2F5D8A"/>
+            </a:solidFill>
+            <a:prstDash val="solid"/>
+          </a:ln>
+        </p:spPr>
+        <p:txBody>
+          <a:bodyPr wrap="square" lIns="38100" tIns="25400" rIns="38100" bIns="25400" rtlCol="0" anchor="ctr"/>
+          <a:lstStyle/>
+          <a:p>
+            <a:pPr algn="ctr" indent="0" marL="0">
+              <a:buNone/>
+            </a:pPr>
+            <a:r>
+              <a:rPr lang="en-US" sz="1100" dirty="0">
+                <a:solidFill>
+                  <a:srgbClr val="1F2328"/>
+                </a:solidFill>
+                <a:latin typeface="Arial" pitchFamily="34" charset="0"/>
+                <a:ea typeface="Arial" pitchFamily="34" charset="-122"/>
+                <a:cs typeface="Arial" pitchFamily="34" charset="-120"/>
+              </a:rPr>
+              <a:t>cFS Library</a:t>
+            </a:r>
+            <a:endParaRPr lang="en-US" sz="1100" dirty="0"/>
+          </a:p>
+        </p:txBody>
+      </p:sp>
+      <p:sp>
+        <p:nvSpPr>
+          <p:cNvPr id="23" name="Mission Library"/>
+          <p:cNvSpPr/>
+          <p:nvPr/>
+        </p:nvSpPr>
+        <p:spPr>
+          <a:xfrm>
+            <a:off x="2871216" y="2404872"/>
+            <a:ext cx="1188720" cy="365760"/>
+          </a:xfrm>
+          <a:prstGeom prst="rect">
+            <a:avLst/>
+          </a:prstGeom>
+          <a:solidFill>
+            <a:srgbClr val="FBE4D2"/>
+          </a:solidFill>
+          <a:ln w="15875">
+            <a:solidFill>
+              <a:srgbClr val="B85F1E"/>
+            </a:solidFill>
+            <a:prstDash val="solid"/>
+          </a:ln>
+        </p:spPr>
+        <p:txBody>
+          <a:bodyPr wrap="square" lIns="38100" tIns="25400" rIns="38100" bIns="25400" rtlCol="0" anchor="ctr"/>
+          <a:lstStyle/>
+          <a:p>
+            <a:pPr algn="ctr" indent="0" marL="0">
+              <a:buNone/>
+            </a:pPr>
+            <a:r>
+              <a:rPr lang="en-US" sz="1100" dirty="0">
+                <a:solidFill>
+                  <a:srgbClr val="1F2328"/>
+                </a:solidFill>
+                <a:latin typeface="Arial" pitchFamily="34" charset="0"/>
+                <a:ea typeface="Arial" pitchFamily="34" charset="-122"/>
+                <a:cs typeface="Arial" pitchFamily="34" charset="-120"/>
+              </a:rPr>
+              <a:t>Mission Library</a:t>
+            </a:r>
+            <a:endParaRPr lang="en-US" sz="1100" dirty="0"/>
+          </a:p>
+        </p:txBody>
+      </p:sp>
+      <p:sp>
+        <p:nvSpPr>
+          <p:cNvPr id="24" name="cFE API"/>
+          <p:cNvSpPr/>
+          <p:nvPr/>
+        </p:nvSpPr>
+        <p:spPr>
+          <a:xfrm>
+            <a:off x="1572768" y="2944368"/>
+            <a:ext cx="6108192" cy="246888"/>
+          </a:xfrm>
+          <a:prstGeom prst="rect">
+            <a:avLst/>
+          </a:prstGeom>
+          <a:solidFill>
+            <a:srgbClr val="2F5D8A"/>
+          </a:solidFill>
+          <a:ln/>
+        </p:spPr>
+        <p:txBody>
+          <a:bodyPr wrap="square" lIns="38100" tIns="25400" rIns="38100" bIns="25400" rtlCol="0" anchor="ctr"/>
+          <a:lstStyle/>
+          <a:p>
+            <a:pPr algn="ctr" indent="0" marL="0">
+              <a:buNone/>
+            </a:pPr>
+            <a:r>
+              <a:rPr lang="en-US" sz="1100" b="1" dirty="0">
+                <a:solidFill>
+                  <a:srgbClr val="FFFFFF"/>
+                </a:solidFill>
+                <a:latin typeface="Arial" pitchFamily="34" charset="0"/>
+                <a:ea typeface="Arial" pitchFamily="34" charset="-122"/>
+                <a:cs typeface="Arial" pitchFamily="34" charset="-120"/>
+              </a:rPr>
+              <a:t>cFE API</a:t>
+            </a:r>
+            <a:endParaRPr lang="en-US" sz="1100" dirty="0"/>
+          </a:p>
+        </p:txBody>
+      </p:sp>
+      <p:sp>
+        <p:nvSpPr>
+          <p:cNvPr id="25" name="cFE Core"/>
+          <p:cNvSpPr/>
+          <p:nvPr/>
+        </p:nvSpPr>
+        <p:spPr>
+          <a:xfrm>
+            <a:off x="1572768" y="3273552"/>
+            <a:ext cx="3017520" cy="640080"/>
+          </a:xfrm>
+          <a:prstGeom prst="rect">
+            <a:avLst/>
+          </a:prstGeom>
+          <a:solidFill>
+            <a:srgbClr val="DCE6F0"/>
+          </a:solidFill>
+          <a:ln w="12700">
+            <a:solidFill>
+              <a:srgbClr val="2F5D8A"/>
+            </a:solidFill>
+            <a:prstDash val="solid"/>
+          </a:ln>
+        </p:spPr>
+      </p:sp>
+      <p:sp>
+        <p:nvSpPr>
+          <p:cNvPr id="26" name="Badge 1 cFE services"/>
+          <p:cNvSpPr/>
+          <p:nvPr/>
+        </p:nvSpPr>
+        <p:spPr>
+          <a:xfrm>
+            <a:off x="1636776" y="3474720"/>
+            <a:ext cx="237744" cy="237744"/>
+          </a:xfrm>
+          <a:prstGeom prst="ellipse">
+            <a:avLst/>
+          </a:prstGeom>
+          <a:solidFill>
+            <a:srgbClr val="1F2328"/>
+          </a:solidFill>
+          <a:ln/>
+        </p:spPr>
+        <p:txBody>
+          <a:bodyPr wrap="square" lIns="0" tIns="0" rIns="0" bIns="0" rtlCol="0" anchor="ctr"/>
+          <a:lstStyle/>
+          <a:p>
+            <a:pPr algn="ctr" indent="0" marL="0">
+              <a:buNone/>
+            </a:pPr>
+            <a:r>
+              <a:rPr lang="en-US" sz="1100" b="1" dirty="0">
+                <a:solidFill>
+                  <a:srgbClr val="FFFFFF"/>
+                </a:solidFill>
+                <a:latin typeface="Arial" pitchFamily="34" charset="0"/>
+                <a:ea typeface="Arial" pitchFamily="34" charset="-122"/>
+                <a:cs typeface="Arial" pitchFamily="34" charset="-120"/>
+              </a:rPr>
+              <a:t>1</a:t>
+            </a:r>
+            <a:endParaRPr lang="en-US" sz="1100" dirty="0"/>
+          </a:p>
+        </p:txBody>
+      </p:sp>
+      <p:sp>
+        <p:nvSpPr>
+          <p:cNvPr id="27" name="cFE Core label"/>
+          <p:cNvSpPr/>
+          <p:nvPr/>
+        </p:nvSpPr>
+        <p:spPr>
+          <a:xfrm>
+            <a:off x="1920240" y="3438144"/>
+            <a:ext cx="731520" cy="310896"/>
+          </a:xfrm>
+          <a:prstGeom prst="rect">
+            <a:avLst/>
+          </a:prstGeom>
+          <a:noFill/>
+          <a:ln/>
+        </p:spPr>
+        <p:txBody>
+          <a:bodyPr wrap="square" lIns="0" tIns="0" rIns="0" bIns="0" rtlCol="0" anchor="ctr"/>
+          <a:lstStyle/>
+          <a:p>
+            <a:pPr algn="l" indent="0" marL="0">
+              <a:buNone/>
+            </a:pPr>
+            <a:r>
+              <a:rPr lang="en-US" sz="1200" b="1" dirty="0">
+                <a:solidFill>
+                  <a:srgbClr val="1F2328"/>
+                </a:solidFill>
+                <a:latin typeface="Arial" pitchFamily="34" charset="0"/>
+                <a:ea typeface="Arial" pitchFamily="34" charset="-122"/>
+                <a:cs typeface="Arial" pitchFamily="34" charset="-120"/>
+              </a:rPr>
+              <a:t>cFE Core</a:t>
+            </a:r>
+            <a:endParaRPr lang="en-US" sz="1200" dirty="0"/>
+          </a:p>
+        </p:txBody>
+      </p:sp>
+      <p:sp>
+        <p:nvSpPr>
+          <p:cNvPr id="28" name="cFE service ES"/>
+          <p:cNvSpPr/>
+          <p:nvPr/>
+        </p:nvSpPr>
+        <p:spPr>
+          <a:xfrm>
+            <a:off x="2670048" y="3611880"/>
+            <a:ext cx="347472" cy="246888"/>
+          </a:xfrm>
+          <a:prstGeom prst="rect">
+            <a:avLst/>
+          </a:prstGeom>
+          <a:solidFill>
+            <a:srgbClr val="FFFFFF"/>
+          </a:solidFill>
+          <a:ln w="9525">
+            <a:solidFill>
+              <a:srgbClr val="2F5D8A"/>
+            </a:solidFill>
+            <a:prstDash val="solid"/>
+          </a:ln>
+        </p:spPr>
+        <p:txBody>
+          <a:bodyPr wrap="square" lIns="12700" tIns="12700" rIns="12700" bIns="12700" rtlCol="0" anchor="ctr"/>
+          <a:lstStyle/>
+          <a:p>
+            <a:pPr algn="ctr" indent="0" marL="0">
+              <a:buNone/>
+            </a:pPr>
+            <a:r>
+              <a:rPr lang="en-US" sz="1000" b="1" dirty="0">
+                <a:solidFill>
+                  <a:srgbClr val="1F2328"/>
+                </a:solidFill>
+                <a:latin typeface="Arial" pitchFamily="34" charset="0"/>
+                <a:ea typeface="Arial" pitchFamily="34" charset="-122"/>
+                <a:cs typeface="Arial" pitchFamily="34" charset="-120"/>
+              </a:rPr>
+              <a:t>ES</a:t>
+            </a:r>
+            <a:endParaRPr lang="en-US" sz="1000" dirty="0"/>
+          </a:p>
+        </p:txBody>
+      </p:sp>
+      <p:sp>
+        <p:nvSpPr>
+          <p:cNvPr id="29" name="cFE service SB"/>
+          <p:cNvSpPr/>
+          <p:nvPr/>
+        </p:nvSpPr>
+        <p:spPr>
+          <a:xfrm>
+            <a:off x="3054096" y="3611880"/>
+            <a:ext cx="347472" cy="246888"/>
+          </a:xfrm>
+          <a:prstGeom prst="rect">
+            <a:avLst/>
+          </a:prstGeom>
+          <a:solidFill>
+            <a:srgbClr val="FFFFFF"/>
+          </a:solidFill>
+          <a:ln w="9525">
+            <a:solidFill>
+              <a:srgbClr val="2F5D8A"/>
+            </a:solidFill>
+            <a:prstDash val="solid"/>
+          </a:ln>
+        </p:spPr>
+        <p:txBody>
+          <a:bodyPr wrap="square" lIns="12700" tIns="12700" rIns="12700" bIns="12700" rtlCol="0" anchor="ctr"/>
+          <a:lstStyle/>
+          <a:p>
+            <a:pPr algn="ctr" indent="0" marL="0">
+              <a:buNone/>
+            </a:pPr>
+            <a:r>
+              <a:rPr lang="en-US" sz="1000" b="1" dirty="0">
+                <a:solidFill>
+                  <a:srgbClr val="1F2328"/>
+                </a:solidFill>
+                <a:latin typeface="Arial" pitchFamily="34" charset="0"/>
+                <a:ea typeface="Arial" pitchFamily="34" charset="-122"/>
+                <a:cs typeface="Arial" pitchFamily="34" charset="-120"/>
+              </a:rPr>
+              <a:t>SB</a:t>
+            </a:r>
+            <a:endParaRPr lang="en-US" sz="1000" dirty="0"/>
+          </a:p>
+        </p:txBody>
+      </p:sp>
+      <p:sp>
+        <p:nvSpPr>
+          <p:cNvPr id="30" name="Badge 2 software bus"/>
+          <p:cNvSpPr/>
+          <p:nvPr/>
+        </p:nvSpPr>
+        <p:spPr>
+          <a:xfrm>
+            <a:off x="3108960" y="3328416"/>
+            <a:ext cx="237744" cy="237744"/>
+          </a:xfrm>
+          <a:prstGeom prst="ellipse">
+            <a:avLst/>
+          </a:prstGeom>
+          <a:solidFill>
+            <a:srgbClr val="1F2328"/>
+          </a:solidFill>
+          <a:ln/>
+        </p:spPr>
+        <p:txBody>
+          <a:bodyPr wrap="square" lIns="0" tIns="0" rIns="0" bIns="0" rtlCol="0" anchor="ctr"/>
+          <a:lstStyle/>
+          <a:p>
+            <a:pPr algn="ctr" indent="0" marL="0">
+              <a:buNone/>
+            </a:pPr>
+            <a:r>
+              <a:rPr lang="en-US" sz="1100" b="1" dirty="0">
+                <a:solidFill>
+                  <a:srgbClr val="FFFFFF"/>
+                </a:solidFill>
+                <a:latin typeface="Arial" pitchFamily="34" charset="0"/>
+                <a:ea typeface="Arial" pitchFamily="34" charset="-122"/>
+                <a:cs typeface="Arial" pitchFamily="34" charset="-120"/>
+              </a:rPr>
+              <a:t>2</a:t>
+            </a:r>
+            <a:endParaRPr lang="en-US" sz="1100" dirty="0"/>
+          </a:p>
+        </p:txBody>
+      </p:sp>
+      <p:sp>
+        <p:nvSpPr>
+          <p:cNvPr id="31" name="cFE service EVS"/>
+          <p:cNvSpPr/>
+          <p:nvPr/>
+        </p:nvSpPr>
+        <p:spPr>
+          <a:xfrm>
+            <a:off x="3438144" y="3611880"/>
+            <a:ext cx="347472" cy="246888"/>
+          </a:xfrm>
+          <a:prstGeom prst="rect">
+            <a:avLst/>
+          </a:prstGeom>
+          <a:solidFill>
+            <a:srgbClr val="FFFFFF"/>
+          </a:solidFill>
+          <a:ln w="9525">
+            <a:solidFill>
+              <a:srgbClr val="2F5D8A"/>
+            </a:solidFill>
+            <a:prstDash val="solid"/>
+          </a:ln>
+        </p:spPr>
+        <p:txBody>
+          <a:bodyPr wrap="square" lIns="12700" tIns="12700" rIns="12700" bIns="12700" rtlCol="0" anchor="ctr"/>
+          <a:lstStyle/>
+          <a:p>
+            <a:pPr algn="ctr" indent="0" marL="0">
+              <a:buNone/>
+            </a:pPr>
+            <a:r>
+              <a:rPr lang="en-US" sz="1000" b="1" dirty="0">
+                <a:solidFill>
+                  <a:srgbClr val="1F2328"/>
+                </a:solidFill>
+                <a:latin typeface="Arial" pitchFamily="34" charset="0"/>
+                <a:ea typeface="Arial" pitchFamily="34" charset="-122"/>
+                <a:cs typeface="Arial" pitchFamily="34" charset="-120"/>
+              </a:rPr>
+              <a:t>EVS</a:t>
+            </a:r>
+            <a:endParaRPr lang="en-US" sz="1000" dirty="0"/>
+          </a:p>
+        </p:txBody>
+      </p:sp>
+      <p:sp>
+        <p:nvSpPr>
+          <p:cNvPr id="32" name="cFE service TIME"/>
+          <p:cNvSpPr/>
+          <p:nvPr/>
+        </p:nvSpPr>
+        <p:spPr>
+          <a:xfrm>
+            <a:off x="3822192" y="3611880"/>
+            <a:ext cx="347472" cy="246888"/>
+          </a:xfrm>
+          <a:prstGeom prst="rect">
+            <a:avLst/>
+          </a:prstGeom>
+          <a:solidFill>
+            <a:srgbClr val="FFFFFF"/>
+          </a:solidFill>
+          <a:ln w="9525">
+            <a:solidFill>
+              <a:srgbClr val="2F5D8A"/>
+            </a:solidFill>
+            <a:prstDash val="solid"/>
+          </a:ln>
+        </p:spPr>
+        <p:txBody>
+          <a:bodyPr wrap="square" lIns="12700" tIns="12700" rIns="12700" bIns="12700" rtlCol="0" anchor="ctr"/>
+          <a:lstStyle/>
+          <a:p>
+            <a:pPr algn="ctr" indent="0" marL="0">
+              <a:buNone/>
+            </a:pPr>
+            <a:r>
+              <a:rPr lang="en-US" sz="1000" b="1" dirty="0">
+                <a:solidFill>
+                  <a:srgbClr val="1F2328"/>
+                </a:solidFill>
+                <a:latin typeface="Arial" pitchFamily="34" charset="0"/>
+                <a:ea typeface="Arial" pitchFamily="34" charset="-122"/>
+                <a:cs typeface="Arial" pitchFamily="34" charset="-120"/>
+              </a:rPr>
+              <a:t>TIME</a:t>
+            </a:r>
+            <a:endParaRPr lang="en-US" sz="1000" dirty="0"/>
+          </a:p>
+        </p:txBody>
+      </p:sp>
+      <p:sp>
+        <p:nvSpPr>
+          <p:cNvPr id="33" name="cFE service TBL"/>
+          <p:cNvSpPr/>
+          <p:nvPr/>
+        </p:nvSpPr>
+        <p:spPr>
+          <a:xfrm>
+            <a:off x="4206240" y="3611880"/>
+            <a:ext cx="347472" cy="246888"/>
+          </a:xfrm>
+          <a:prstGeom prst="rect">
+            <a:avLst/>
+          </a:prstGeom>
+          <a:solidFill>
+            <a:srgbClr val="FFFFFF"/>
+          </a:solidFill>
+          <a:ln w="9525">
+            <a:solidFill>
+              <a:srgbClr val="2F5D8A"/>
+            </a:solidFill>
+            <a:prstDash val="solid"/>
+          </a:ln>
+        </p:spPr>
+        <p:txBody>
+          <a:bodyPr wrap="square" lIns="12700" tIns="12700" rIns="12700" bIns="12700" rtlCol="0" anchor="ctr"/>
+          <a:lstStyle/>
+          <a:p>
+            <a:pPr algn="ctr" indent="0" marL="0">
+              <a:buNone/>
+            </a:pPr>
+            <a:r>
+              <a:rPr lang="en-US" sz="1000" b="1" dirty="0">
+                <a:solidFill>
+                  <a:srgbClr val="1F2328"/>
+                </a:solidFill>
+                <a:latin typeface="Arial" pitchFamily="34" charset="0"/>
+                <a:ea typeface="Arial" pitchFamily="34" charset="-122"/>
+                <a:cs typeface="Arial" pitchFamily="34" charset="-120"/>
+              </a:rPr>
+              <a:t>TBL</a:t>
+            </a:r>
+            <a:endParaRPr lang="en-US" sz="1000" dirty="0"/>
+          </a:p>
+        </p:txBody>
+      </p:sp>
+      <p:sp>
+        <p:nvSpPr>
+          <p:cNvPr id="34" name="micro cFE Core"/>
+          <p:cNvSpPr/>
+          <p:nvPr/>
+        </p:nvSpPr>
+        <p:spPr>
+          <a:xfrm>
+            <a:off x="4700016" y="3273552"/>
+            <a:ext cx="914400" cy="640080"/>
+          </a:xfrm>
+          <a:prstGeom prst="rect">
+            <a:avLst/>
+          </a:prstGeom>
+          <a:solidFill>
+            <a:srgbClr val="FFFFFF"/>
+          </a:solidFill>
+          <a:ln w="15875">
+            <a:solidFill>
+              <a:srgbClr val="2F5D8A"/>
+            </a:solidFill>
+            <a:prstDash val="dash"/>
+          </a:ln>
+        </p:spPr>
+        <p:txBody>
+          <a:bodyPr wrap="square" lIns="38100" tIns="25400" rIns="38100" bIns="25400" rtlCol="0" anchor="ctr"/>
+          <a:lstStyle/>
+          <a:p>
+            <a:pPr algn="ctr" indent="0" marL="0">
+              <a:buNone/>
+            </a:pPr>
+            <a:r>
+              <a:rPr lang="en-US" sz="1100" dirty="0">
+                <a:solidFill>
+                  <a:srgbClr val="1F2328"/>
+                </a:solidFill>
+                <a:latin typeface="Arial" pitchFamily="34" charset="0"/>
+                <a:ea typeface="Arial" pitchFamily="34" charset="-122"/>
+                <a:cs typeface="Arial" pitchFamily="34" charset="-120"/>
+              </a:rPr>
+              <a:t>µcFE Core</a:t>
+            </a:r>
+            <a:endParaRPr lang="en-US" sz="1100" dirty="0"/>
+          </a:p>
+        </p:txBody>
+      </p:sp>
+      <p:sp>
+        <p:nvSpPr>
+          <p:cNvPr id="35" name="TSP cFE Core"/>
+          <p:cNvSpPr/>
+          <p:nvPr/>
+        </p:nvSpPr>
+        <p:spPr>
+          <a:xfrm>
+            <a:off x="5724144" y="3273552"/>
+            <a:ext cx="1956816" cy="640080"/>
+          </a:xfrm>
+          <a:prstGeom prst="rect">
+            <a:avLst/>
+          </a:prstGeom>
+          <a:solidFill>
+            <a:srgbClr val="FFFFFF"/>
+          </a:solidFill>
+          <a:ln w="15875">
+            <a:solidFill>
+              <a:srgbClr val="2F5D8A"/>
+            </a:solidFill>
+            <a:prstDash val="dash"/>
+          </a:ln>
+        </p:spPr>
+        <p:txBody>
+          <a:bodyPr wrap="square" lIns="38100" tIns="25400" rIns="38100" bIns="25400" rtlCol="0" anchor="ctr"/>
+          <a:lstStyle/>
+          <a:p>
+            <a:pPr algn="ctr" indent="0" marL="0">
+              <a:buNone/>
+            </a:pPr>
+            <a:r>
+              <a:rPr lang="en-US" sz="1100" dirty="0">
+                <a:solidFill>
+                  <a:srgbClr val="1F2328"/>
+                </a:solidFill>
+                <a:latin typeface="Arial" pitchFamily="34" charset="0"/>
+                <a:ea typeface="Arial" pitchFamily="34" charset="-122"/>
+                <a:cs typeface="Arial" pitchFamily="34" charset="-120"/>
+              </a:rPr>
+              <a:t>Time &amp; Space Partitioning (TSP) cFE Core</a:t>
+            </a:r>
+            <a:endParaRPr lang="en-US" sz="1100" dirty="0"/>
+          </a:p>
+        </p:txBody>
+      </p:sp>
+      <p:sp>
+        <p:nvSpPr>
+          <p:cNvPr id="36" name="OS Abstraction API"/>
+          <p:cNvSpPr/>
+          <p:nvPr/>
+        </p:nvSpPr>
+        <p:spPr>
+          <a:xfrm>
+            <a:off x="1572768" y="4078224"/>
+            <a:ext cx="4498848" cy="246888"/>
+          </a:xfrm>
+          <a:prstGeom prst="rect">
+            <a:avLst/>
+          </a:prstGeom>
+          <a:solidFill>
+            <a:srgbClr val="2F5D8A"/>
+          </a:solidFill>
+          <a:ln/>
+        </p:spPr>
+        <p:txBody>
+          <a:bodyPr wrap="square" lIns="38100" tIns="25400" rIns="38100" bIns="25400" rtlCol="0" anchor="ctr"/>
+          <a:lstStyle/>
+          <a:p>
+            <a:pPr algn="ctr" indent="0" marL="0">
+              <a:buNone/>
+            </a:pPr>
+            <a:r>
+              <a:rPr lang="en-US" sz="1100" b="1" dirty="0">
+                <a:solidFill>
+                  <a:srgbClr val="FFFFFF"/>
+                </a:solidFill>
+                <a:latin typeface="Arial" pitchFamily="34" charset="0"/>
+                <a:ea typeface="Arial" pitchFamily="34" charset="-122"/>
+                <a:cs typeface="Arial" pitchFamily="34" charset="-120"/>
+              </a:rPr>
+              <a:t>OS Abstraction API</a:t>
+            </a:r>
+            <a:endParaRPr lang="en-US" sz="1100" dirty="0"/>
+          </a:p>
+        </p:txBody>
+      </p:sp>
+      <p:sp>
+        <p:nvSpPr>
+          <p:cNvPr id="37" name="Badge 3 OSAL"/>
+          <p:cNvSpPr/>
+          <p:nvPr/>
+        </p:nvSpPr>
+        <p:spPr>
+          <a:xfrm>
+            <a:off x="1609344" y="4082796"/>
+            <a:ext cx="237744" cy="237744"/>
+          </a:xfrm>
+          <a:prstGeom prst="ellipse">
+            <a:avLst/>
+          </a:prstGeom>
+          <a:solidFill>
+            <a:srgbClr val="1F2328"/>
+          </a:solidFill>
+          <a:ln/>
+        </p:spPr>
+        <p:txBody>
+          <a:bodyPr wrap="square" lIns="0" tIns="0" rIns="0" bIns="0" rtlCol="0" anchor="ctr"/>
+          <a:lstStyle/>
+          <a:p>
+            <a:pPr algn="ctr" indent="0" marL="0">
+              <a:buNone/>
+            </a:pPr>
+            <a:r>
+              <a:rPr lang="en-US" sz="1100" b="1" dirty="0">
+                <a:solidFill>
+                  <a:srgbClr val="FFFFFF"/>
+                </a:solidFill>
+                <a:latin typeface="Arial" pitchFamily="34" charset="0"/>
+                <a:ea typeface="Arial" pitchFamily="34" charset="-122"/>
+                <a:cs typeface="Arial" pitchFamily="34" charset="-120"/>
+              </a:rPr>
+              <a:t>3</a:t>
+            </a:r>
+            <a:endParaRPr lang="en-US" sz="1100" dirty="0"/>
+          </a:p>
+        </p:txBody>
+      </p:sp>
+      <p:sp>
+        <p:nvSpPr>
+          <p:cNvPr id="38" name="cFE PSP API"/>
+          <p:cNvSpPr/>
+          <p:nvPr/>
+        </p:nvSpPr>
+        <p:spPr>
+          <a:xfrm>
+            <a:off x="6181344" y="4078224"/>
+            <a:ext cx="1499616" cy="246888"/>
+          </a:xfrm>
+          <a:prstGeom prst="rect">
+            <a:avLst/>
+          </a:prstGeom>
+          <a:solidFill>
+            <a:srgbClr val="2F5D8A"/>
+          </a:solidFill>
+          <a:ln/>
+        </p:spPr>
+        <p:txBody>
+          <a:bodyPr wrap="square" lIns="38100" tIns="25400" rIns="38100" bIns="25400" rtlCol="0" anchor="ctr"/>
+          <a:lstStyle/>
+          <a:p>
+            <a:pPr algn="ctr" indent="0" marL="0">
+              <a:buNone/>
+            </a:pPr>
+            <a:r>
+              <a:rPr lang="en-US" sz="1100" b="1" dirty="0">
+                <a:solidFill>
+                  <a:srgbClr val="FFFFFF"/>
+                </a:solidFill>
+                <a:latin typeface="Arial" pitchFamily="34" charset="0"/>
+                <a:ea typeface="Arial" pitchFamily="34" charset="-122"/>
+                <a:cs typeface="Arial" pitchFamily="34" charset="-120"/>
+              </a:rPr>
+              <a:t>cFE PSP API</a:t>
+            </a:r>
+            <a:endParaRPr lang="en-US" sz="1100" dirty="0"/>
+          </a:p>
+        </p:txBody>
+      </p:sp>
+      <p:sp>
+        <p:nvSpPr>
+          <p:cNvPr id="39" name="Badge 4 PSP"/>
+          <p:cNvSpPr/>
+          <p:nvPr/>
+        </p:nvSpPr>
+        <p:spPr>
+          <a:xfrm>
+            <a:off x="6217920" y="4082796"/>
+            <a:ext cx="237744" cy="237744"/>
+          </a:xfrm>
+          <a:prstGeom prst="ellipse">
+            <a:avLst/>
+          </a:prstGeom>
+          <a:solidFill>
+            <a:srgbClr val="1F2328"/>
+          </a:solidFill>
+          <a:ln/>
+        </p:spPr>
+        <p:txBody>
+          <a:bodyPr wrap="square" lIns="0" tIns="0" rIns="0" bIns="0" rtlCol="0" anchor="ctr"/>
+          <a:lstStyle/>
+          <a:p>
+            <a:pPr algn="ctr" indent="0" marL="0">
+              <a:buNone/>
+            </a:pPr>
+            <a:r>
+              <a:rPr lang="en-US" sz="1100" b="1" dirty="0">
+                <a:solidFill>
+                  <a:srgbClr val="FFFFFF"/>
+                </a:solidFill>
+                <a:latin typeface="Arial" pitchFamily="34" charset="0"/>
+                <a:ea typeface="Arial" pitchFamily="34" charset="-122"/>
+                <a:cs typeface="Arial" pitchFamily="34" charset="-120"/>
+              </a:rPr>
+              <a:t>4</a:t>
+            </a:r>
+            <a:endParaRPr lang="en-US" sz="1100" dirty="0"/>
+          </a:p>
+        </p:txBody>
+      </p:sp>
+      <p:sp>
+        <p:nvSpPr>
+          <p:cNvPr id="40" name="OS Abstraction Linux"/>
+          <p:cNvSpPr/>
+          <p:nvPr/>
+        </p:nvSpPr>
+        <p:spPr>
+          <a:xfrm>
+            <a:off x="1572768" y="4398264"/>
+            <a:ext cx="1042416" cy="493776"/>
+          </a:xfrm>
+          <a:prstGeom prst="rect">
+            <a:avLst/>
+          </a:prstGeom>
+          <a:solidFill>
+            <a:srgbClr val="DCE6F0"/>
+          </a:solidFill>
+          <a:ln w="12700">
+            <a:solidFill>
+              <a:srgbClr val="2F5D8A"/>
+            </a:solidFill>
+            <a:prstDash val="solid"/>
+          </a:ln>
+        </p:spPr>
+        <p:txBody>
+          <a:bodyPr wrap="square" lIns="38100" tIns="25400" rIns="38100" bIns="25400" rtlCol="0" anchor="ctr"/>
+          <a:lstStyle/>
+          <a:p>
+            <a:pPr algn="ctr" indent="0" marL="0">
+              <a:buNone/>
+            </a:pPr>
+            <a:r>
+              <a:rPr lang="en-US" sz="1100" dirty="0">
+                <a:solidFill>
+                  <a:srgbClr val="1F2328"/>
+                </a:solidFill>
+                <a:latin typeface="Arial" pitchFamily="34" charset="0"/>
+                <a:ea typeface="Arial" pitchFamily="34" charset="-122"/>
+                <a:cs typeface="Arial" pitchFamily="34" charset="-120"/>
+              </a:rPr>
+              <a:t>OS Abstraction Linux</a:t>
+            </a:r>
+            <a:endParaRPr lang="en-US" sz="1100" dirty="0"/>
+          </a:p>
+        </p:txBody>
+      </p:sp>
+      <p:sp>
+        <p:nvSpPr>
+          <p:cNvPr id="41" name="OS Abstraction RTEMS"/>
+          <p:cNvSpPr/>
+          <p:nvPr/>
+        </p:nvSpPr>
+        <p:spPr>
+          <a:xfrm>
+            <a:off x="2724912" y="4398264"/>
+            <a:ext cx="1042416" cy="493776"/>
+          </a:xfrm>
+          <a:prstGeom prst="rect">
+            <a:avLst/>
+          </a:prstGeom>
+          <a:solidFill>
+            <a:srgbClr val="DCE6F0"/>
+          </a:solidFill>
+          <a:ln w="12700">
+            <a:solidFill>
+              <a:srgbClr val="2F5D8A"/>
+            </a:solidFill>
+            <a:prstDash val="solid"/>
+          </a:ln>
+        </p:spPr>
+        <p:txBody>
+          <a:bodyPr wrap="square" lIns="38100" tIns="25400" rIns="38100" bIns="25400" rtlCol="0" anchor="ctr"/>
+          <a:lstStyle/>
+          <a:p>
+            <a:pPr algn="ctr" indent="0" marL="0">
+              <a:buNone/>
+            </a:pPr>
+            <a:r>
+              <a:rPr lang="en-US" sz="1100" dirty="0">
+                <a:solidFill>
+                  <a:srgbClr val="1F2328"/>
+                </a:solidFill>
+                <a:latin typeface="Arial" pitchFamily="34" charset="0"/>
+                <a:ea typeface="Arial" pitchFamily="34" charset="-122"/>
+                <a:cs typeface="Arial" pitchFamily="34" charset="-120"/>
+              </a:rPr>
+              <a:t>OS Abstraction RTEMS</a:t>
+            </a:r>
+            <a:endParaRPr lang="en-US" sz="1100" dirty="0"/>
+          </a:p>
+        </p:txBody>
+      </p:sp>
+      <p:sp>
+        <p:nvSpPr>
+          <p:cNvPr id="42" name="OS Abstraction VxWorks"/>
+          <p:cNvSpPr/>
+          <p:nvPr/>
+        </p:nvSpPr>
+        <p:spPr>
+          <a:xfrm>
+            <a:off x="3877056" y="4398264"/>
+            <a:ext cx="1042416" cy="493776"/>
+          </a:xfrm>
+          <a:prstGeom prst="rect">
+            <a:avLst/>
+          </a:prstGeom>
+          <a:solidFill>
+            <a:srgbClr val="FFFFFF"/>
+          </a:solidFill>
+          <a:ln w="9525">
+            <a:solidFill>
+              <a:srgbClr val="7C8591"/>
+            </a:solidFill>
+            <a:prstDash val="solid"/>
+          </a:ln>
+        </p:spPr>
+        <p:txBody>
+          <a:bodyPr wrap="square" lIns="38100" tIns="25400" rIns="38100" bIns="25400" rtlCol="0" anchor="ctr"/>
+          <a:lstStyle/>
+          <a:p>
+            <a:pPr algn="ctr" indent="0" marL="0">
+              <a:buNone/>
+            </a:pPr>
+            <a:r>
+              <a:rPr lang="en-US" sz="1100" dirty="0">
+                <a:solidFill>
+                  <a:srgbClr val="1F2328"/>
+                </a:solidFill>
+                <a:latin typeface="Arial" pitchFamily="34" charset="0"/>
+                <a:ea typeface="Arial" pitchFamily="34" charset="-122"/>
+                <a:cs typeface="Arial" pitchFamily="34" charset="-120"/>
+              </a:rPr>
+              <a:t>OS Abstraction VxWorks</a:t>
+            </a:r>
+            <a:endParaRPr lang="en-US" sz="1100" dirty="0"/>
+          </a:p>
+        </p:txBody>
+      </p:sp>
+      <p:sp>
+        <p:nvSpPr>
+          <p:cNvPr id="43" name="OS Abstraction TSP"/>
+          <p:cNvSpPr/>
+          <p:nvPr/>
+        </p:nvSpPr>
+        <p:spPr>
+          <a:xfrm>
+            <a:off x="5029200" y="4398264"/>
+            <a:ext cx="1042416" cy="493776"/>
+          </a:xfrm>
+          <a:prstGeom prst="rect">
+            <a:avLst/>
+          </a:prstGeom>
+          <a:solidFill>
+            <a:srgbClr val="FFFFFF"/>
+          </a:solidFill>
+          <a:ln w="9525">
+            <a:solidFill>
+              <a:srgbClr val="7C8591"/>
+            </a:solidFill>
+            <a:prstDash val="solid"/>
+          </a:ln>
+        </p:spPr>
+        <p:txBody>
+          <a:bodyPr wrap="square" lIns="38100" tIns="25400" rIns="38100" bIns="25400" rtlCol="0" anchor="ctr"/>
+          <a:lstStyle/>
+          <a:p>
+            <a:pPr algn="ctr" indent="0" marL="0">
+              <a:buNone/>
+            </a:pPr>
+            <a:r>
+              <a:rPr lang="en-US" sz="1100" dirty="0">
+                <a:solidFill>
+                  <a:srgbClr val="1F2328"/>
+                </a:solidFill>
+                <a:latin typeface="Arial" pitchFamily="34" charset="0"/>
+                <a:ea typeface="Arial" pitchFamily="34" charset="-122"/>
+                <a:cs typeface="Arial" pitchFamily="34" charset="-120"/>
+              </a:rPr>
+              <a:t>OS Abstraction TSP</a:t>
+            </a:r>
+            <a:endParaRPr lang="en-US" sz="1100" dirty="0"/>
+          </a:p>
+        </p:txBody>
+      </p:sp>
+      <p:sp>
+        <p:nvSpPr>
+          <p:cNvPr id="44" name="PSP stack back"/>
+          <p:cNvSpPr/>
+          <p:nvPr/>
+        </p:nvSpPr>
+        <p:spPr>
+          <a:xfrm>
+            <a:off x="6254496" y="4453128"/>
+            <a:ext cx="1426464" cy="475488"/>
+          </a:xfrm>
+          <a:prstGeom prst="rect">
+            <a:avLst/>
+          </a:prstGeom>
+          <a:solidFill>
+            <a:srgbClr val="FBE4D2"/>
+          </a:solidFill>
+          <a:ln w="15875">
+            <a:solidFill>
+              <a:srgbClr val="B85F1E"/>
+            </a:solidFill>
+            <a:prstDash val="solid"/>
+          </a:ln>
+        </p:spPr>
+      </p:sp>
+      <p:sp>
+        <p:nvSpPr>
+          <p:cNvPr id="45" name="cFE Platform Support Packages"/>
+          <p:cNvSpPr/>
+          <p:nvPr/>
+        </p:nvSpPr>
+        <p:spPr>
+          <a:xfrm>
+            <a:off x="6181344" y="4398264"/>
+            <a:ext cx="1426464" cy="475488"/>
+          </a:xfrm>
+          <a:prstGeom prst="rect">
+            <a:avLst/>
+          </a:prstGeom>
+          <a:solidFill>
+            <a:srgbClr val="FBE4D2"/>
+          </a:solidFill>
+          <a:ln w="15875">
+            <a:solidFill>
+              <a:srgbClr val="B85F1E"/>
+            </a:solidFill>
+            <a:prstDash val="solid"/>
+          </a:ln>
+        </p:spPr>
+        <p:txBody>
+          <a:bodyPr wrap="square" lIns="38100" tIns="25400" rIns="38100" bIns="25400" rtlCol="0" anchor="ctr"/>
+          <a:lstStyle/>
+          <a:p>
+            <a:pPr algn="ctr" indent="0" marL="0">
+              <a:buNone/>
+            </a:pPr>
+            <a:r>
+              <a:rPr lang="en-US" sz="1100" dirty="0">
+                <a:solidFill>
+                  <a:srgbClr val="1F2328"/>
+                </a:solidFill>
+                <a:latin typeface="Arial" pitchFamily="34" charset="0"/>
+                <a:ea typeface="Arial" pitchFamily="34" charset="-122"/>
+                <a:cs typeface="Arial" pitchFamily="34" charset="-120"/>
+              </a:rPr>
+              <a:t>cFE Platform Support Packages</a:t>
+            </a:r>
+            <a:endParaRPr lang="en-US" sz="1100" dirty="0"/>
+          </a:p>
+        </p:txBody>
+      </p:sp>
+      <p:sp>
+        <p:nvSpPr>
+          <p:cNvPr id="46" name="Real Time OS"/>
+          <p:cNvSpPr/>
+          <p:nvPr/>
+        </p:nvSpPr>
+        <p:spPr>
+          <a:xfrm>
+            <a:off x="1572768" y="5102352"/>
+            <a:ext cx="1371600" cy="384048"/>
+          </a:xfrm>
+          <a:prstGeom prst="rect">
+            <a:avLst/>
+          </a:prstGeom>
+          <a:solidFill>
+            <a:srgbClr val="E4E7EB"/>
+          </a:solidFill>
+          <a:ln w="12700">
+            <a:solidFill>
+              <a:srgbClr val="7C8591"/>
+            </a:solidFill>
+            <a:prstDash val="solid"/>
+          </a:ln>
+        </p:spPr>
+        <p:txBody>
+          <a:bodyPr wrap="square" lIns="38100" tIns="25400" rIns="38100" bIns="25400" rtlCol="0" anchor="ctr"/>
+          <a:lstStyle/>
+          <a:p>
+            <a:pPr algn="ctr" indent="0" marL="0">
+              <a:buNone/>
+            </a:pPr>
+            <a:r>
+              <a:rPr lang="en-US" sz="1100" dirty="0">
+                <a:solidFill>
+                  <a:srgbClr val="1F2328"/>
+                </a:solidFill>
+                <a:latin typeface="Arial" pitchFamily="34" charset="0"/>
+                <a:ea typeface="Arial" pitchFamily="34" charset="-122"/>
+                <a:cs typeface="Arial" pitchFamily="34" charset="-120"/>
+              </a:rPr>
+              <a:t>Real Time OS</a:t>
+            </a:r>
+            <a:endParaRPr lang="en-US" sz="1100" dirty="0"/>
+          </a:p>
+        </p:txBody>
+      </p:sp>
+      <p:sp>
+        <p:nvSpPr>
+          <p:cNvPr id="47" name="Board Support Package"/>
+          <p:cNvSpPr/>
+          <p:nvPr/>
+        </p:nvSpPr>
+        <p:spPr>
+          <a:xfrm>
+            <a:off x="2944368" y="5102352"/>
+            <a:ext cx="1627632" cy="384048"/>
+          </a:xfrm>
+          <a:prstGeom prst="rect">
+            <a:avLst/>
+          </a:prstGeom>
+          <a:solidFill>
+            <a:srgbClr val="FBE4D2"/>
+          </a:solidFill>
+          <a:ln w="15875">
+            <a:solidFill>
+              <a:srgbClr val="B85F1E"/>
+            </a:solidFill>
+            <a:prstDash val="solid"/>
+          </a:ln>
+        </p:spPr>
+        <p:txBody>
+          <a:bodyPr wrap="square" lIns="38100" tIns="25400" rIns="38100" bIns="25400" rtlCol="0" anchor="ctr"/>
+          <a:lstStyle/>
+          <a:p>
+            <a:pPr algn="ctr" indent="0" marL="0">
+              <a:buNone/>
+            </a:pPr>
+            <a:r>
+              <a:rPr lang="en-US" sz="1100" dirty="0">
+                <a:solidFill>
+                  <a:srgbClr val="1F2328"/>
+                </a:solidFill>
+                <a:latin typeface="Arial" pitchFamily="34" charset="0"/>
+                <a:ea typeface="Arial" pitchFamily="34" charset="-122"/>
+                <a:cs typeface="Arial" pitchFamily="34" charset="-120"/>
+              </a:rPr>
+              <a:t>Board Support Package</a:t>
+            </a:r>
+            <a:endParaRPr lang="en-US" sz="1100" dirty="0"/>
+          </a:p>
+        </p:txBody>
+      </p:sp>
+      <p:sp>
+        <p:nvSpPr>
+          <p:cNvPr id="48" name="PROM Boot FSW"/>
+          <p:cNvSpPr/>
+          <p:nvPr/>
+        </p:nvSpPr>
+        <p:spPr>
+          <a:xfrm>
+            <a:off x="4681728" y="5102352"/>
+            <a:ext cx="1371600" cy="384048"/>
+          </a:xfrm>
+          <a:prstGeom prst="rect">
+            <a:avLst/>
+          </a:prstGeom>
+          <a:solidFill>
+            <a:srgbClr val="FBE4D2"/>
+          </a:solidFill>
+          <a:ln w="15875">
+            <a:solidFill>
+              <a:srgbClr val="B85F1E"/>
+            </a:solidFill>
+            <a:prstDash val="solid"/>
+          </a:ln>
+        </p:spPr>
+        <p:txBody>
+          <a:bodyPr wrap="square" lIns="38100" tIns="25400" rIns="38100" bIns="25400" rtlCol="0" anchor="ctr"/>
+          <a:lstStyle/>
+          <a:p>
+            <a:pPr algn="ctr" indent="0" marL="0">
+              <a:buNone/>
+            </a:pPr>
+            <a:r>
+              <a:rPr lang="en-US" sz="1100" dirty="0">
+                <a:solidFill>
+                  <a:srgbClr val="1F2328"/>
+                </a:solidFill>
+                <a:latin typeface="Arial" pitchFamily="34" charset="0"/>
+                <a:ea typeface="Arial" pitchFamily="34" charset="-122"/>
+                <a:cs typeface="Arial" pitchFamily="34" charset="-120"/>
+              </a:rPr>
+              <a:t>PROM Boot FSW</a:t>
+            </a:r>
+            <a:endParaRPr lang="en-US" sz="1100" dirty="0"/>
+          </a:p>
+        </p:txBody>
+      </p:sp>
+      <p:sp>
+        <p:nvSpPr>
+          <p:cNvPr id="49" name="Role badge 1"/>
+          <p:cNvSpPr/>
+          <p:nvPr/>
+        </p:nvSpPr>
+        <p:spPr>
+          <a:xfrm>
+            <a:off x="7882128" y="1481328"/>
+            <a:ext cx="256032" cy="256032"/>
+          </a:xfrm>
+          <a:prstGeom prst="ellipse">
+            <a:avLst/>
+          </a:prstGeom>
+          <a:solidFill>
+            <a:srgbClr val="1F2328"/>
+          </a:solidFill>
+          <a:ln/>
+        </p:spPr>
+        <p:txBody>
+          <a:bodyPr wrap="square" lIns="0" tIns="0" rIns="0" bIns="0" rtlCol="0" anchor="ctr"/>
+          <a:lstStyle/>
+          <a:p>
+            <a:pPr algn="ctr" indent="0" marL="0">
+              <a:buNone/>
+            </a:pPr>
+            <a:r>
+              <a:rPr lang="en-US" sz="1200" b="1" dirty="0">
+                <a:solidFill>
+                  <a:srgbClr val="FFFFFF"/>
+                </a:solidFill>
+                <a:latin typeface="Arial" pitchFamily="34" charset="0"/>
+                <a:ea typeface="Arial" pitchFamily="34" charset="-122"/>
+                <a:cs typeface="Arial" pitchFamily="34" charset="-120"/>
+              </a:rPr>
+              <a:t>1</a:t>
+            </a:r>
+            <a:endParaRPr lang="en-US" sz="1200" dirty="0"/>
+          </a:p>
+        </p:txBody>
+      </p:sp>
+      <p:sp>
+        <p:nvSpPr>
+          <p:cNvPr id="50" name="Role 1 name"/>
+          <p:cNvSpPr/>
+          <p:nvPr/>
+        </p:nvSpPr>
+        <p:spPr>
+          <a:xfrm>
+            <a:off x="8247888" y="1481328"/>
+            <a:ext cx="1596568" cy="219456"/>
+          </a:xfrm>
+          <a:prstGeom prst="rect">
+            <a:avLst/>
+          </a:prstGeom>
+          <a:noFill/>
+          <a:ln/>
+        </p:spPr>
+        <p:txBody>
+          <a:bodyPr wrap="square" lIns="0" tIns="0" rIns="0" bIns="0" rtlCol="0" anchor="t"/>
+          <a:lstStyle/>
+          <a:p>
+            <a:pPr algn="l" indent="0" marL="0">
+              <a:buNone/>
+            </a:pPr>
+            <a:r>
+              <a:rPr lang="en-US" sz="1400" b="1" dirty="0">
+                <a:solidFill>
+                  <a:srgbClr val="1F2328"/>
+                </a:solidFill>
+                <a:latin typeface="Arial" pitchFamily="34" charset="0"/>
+                <a:ea typeface="Arial" pitchFamily="34" charset="-122"/>
+                <a:cs typeface="Arial" pitchFamily="34" charset="-120"/>
+              </a:rPr>
+              <a:t>cFE Core services</a:t>
+            </a:r>
+            <a:endParaRPr lang="en-US" sz="1400" dirty="0"/>
+          </a:p>
+        </p:txBody>
+      </p:sp>
+      <p:sp>
+        <p:nvSpPr>
+          <p:cNvPr id="51" name="Role 1 cite"/>
+          <p:cNvSpPr/>
+          <p:nvPr/>
+        </p:nvSpPr>
+        <p:spPr>
+          <a:xfrm>
+            <a:off x="9954184" y="1527048"/>
+            <a:ext cx="1332738" cy="155448"/>
+          </a:xfrm>
+          <a:prstGeom prst="rect">
+            <a:avLst/>
+          </a:prstGeom>
+          <a:noFill/>
+          <a:ln/>
+        </p:spPr>
+        <p:txBody>
+          <a:bodyPr wrap="square" lIns="0" tIns="0" rIns="0" bIns="0" rtlCol="0" anchor="t"/>
+          <a:lstStyle/>
+          <a:p>
+            <a:pPr algn="l" indent="0" marL="0">
+              <a:buNone/>
+            </a:pPr>
+            <a:r>
+              <a:rPr lang="en-US" sz="1000" dirty="0">
+                <a:solidFill>
+                  <a:srgbClr val="565E69"/>
+                </a:solidFill>
+                <a:latin typeface="Arial" pitchFamily="34" charset="0"/>
+                <a:ea typeface="Arial" pitchFamily="34" charset="-122"/>
+                <a:cs typeface="Arial" pitchFamily="34" charset="-120"/>
+              </a:rPr>
+              <a:t>pp. 25, 45, paraphrase</a:t>
+            </a:r>
+            <a:endParaRPr lang="en-US" sz="1000" dirty="0"/>
+          </a:p>
+        </p:txBody>
+      </p:sp>
+      <p:sp>
+        <p:nvSpPr>
+          <p:cNvPr id="52" name="Role 1 text"/>
+          <p:cNvSpPr/>
+          <p:nvPr/>
+        </p:nvSpPr>
+        <p:spPr>
+          <a:xfrm>
+            <a:off x="8247888" y="1709928"/>
+            <a:ext cx="3483864" cy="429768"/>
+          </a:xfrm>
+          <a:prstGeom prst="rect">
+            <a:avLst/>
+          </a:prstGeom>
+          <a:noFill/>
+          <a:ln/>
+        </p:spPr>
+        <p:txBody>
+          <a:bodyPr wrap="square" lIns="0" tIns="0" rIns="0" bIns="0" rtlCol="0" anchor="t"/>
+          <a:lstStyle/>
+          <a:p>
+            <a:pPr algn="l" indent="0" marL="0">
+              <a:buNone/>
+            </a:pPr>
+            <a:r>
+              <a:rPr lang="en-US" sz="1400" dirty="0">
+                <a:solidFill>
+                  <a:srgbClr val="1F2328"/>
+                </a:solidFill>
+                <a:latin typeface="Arial" pitchFamily="34" charset="0"/>
+                <a:ea typeface="Arial" pitchFamily="34" charset="-122"/>
+                <a:cs typeface="Arial" pitchFamily="34" charset="-120"/>
+              </a:rPr>
+              <a:t>Provide the services common to most flight apps: ES, SB, EVS, TIME and TBL</a:t>
+            </a:r>
+            <a:endParaRPr lang="en-US" sz="1400" dirty="0"/>
+          </a:p>
+        </p:txBody>
+      </p:sp>
+      <p:sp>
+        <p:nvSpPr>
+          <p:cNvPr id="53" name="Role badge 2"/>
+          <p:cNvSpPr/>
+          <p:nvPr/>
+        </p:nvSpPr>
+        <p:spPr>
+          <a:xfrm>
+            <a:off x="7882128" y="2304288"/>
+            <a:ext cx="256032" cy="256032"/>
+          </a:xfrm>
+          <a:prstGeom prst="ellipse">
+            <a:avLst/>
+          </a:prstGeom>
+          <a:solidFill>
+            <a:srgbClr val="1F2328"/>
+          </a:solidFill>
+          <a:ln/>
+        </p:spPr>
+        <p:txBody>
+          <a:bodyPr wrap="square" lIns="0" tIns="0" rIns="0" bIns="0" rtlCol="0" anchor="ctr"/>
+          <a:lstStyle/>
+          <a:p>
+            <a:pPr algn="ctr" indent="0" marL="0">
+              <a:buNone/>
+            </a:pPr>
+            <a:r>
+              <a:rPr lang="en-US" sz="1200" b="1" dirty="0">
+                <a:solidFill>
+                  <a:srgbClr val="FFFFFF"/>
+                </a:solidFill>
+                <a:latin typeface="Arial" pitchFamily="34" charset="0"/>
+                <a:ea typeface="Arial" pitchFamily="34" charset="-122"/>
+                <a:cs typeface="Arial" pitchFamily="34" charset="-120"/>
+              </a:rPr>
+              <a:t>2</a:t>
+            </a:r>
+            <a:endParaRPr lang="en-US" sz="1200" dirty="0"/>
+          </a:p>
+        </p:txBody>
+      </p:sp>
+      <p:sp>
+        <p:nvSpPr>
+          <p:cNvPr id="54" name="Role 2 name"/>
+          <p:cNvSpPr/>
+          <p:nvPr/>
+        </p:nvSpPr>
+        <p:spPr>
+          <a:xfrm>
+            <a:off x="8247888" y="2304288"/>
+            <a:ext cx="1586078" cy="219456"/>
+          </a:xfrm>
+          <a:prstGeom prst="rect">
+            <a:avLst/>
+          </a:prstGeom>
+          <a:noFill/>
+          <a:ln/>
+        </p:spPr>
+        <p:txBody>
+          <a:bodyPr wrap="square" lIns="0" tIns="0" rIns="0" bIns="0" rtlCol="0" anchor="t"/>
+          <a:lstStyle/>
+          <a:p>
+            <a:pPr algn="l" indent="0" marL="0">
+              <a:buNone/>
+            </a:pPr>
+            <a:r>
+              <a:rPr lang="en-US" sz="1400" b="1" dirty="0">
+                <a:solidFill>
+                  <a:srgbClr val="1F2328"/>
+                </a:solidFill>
+                <a:latin typeface="Arial" pitchFamily="34" charset="0"/>
+                <a:ea typeface="Arial" pitchFamily="34" charset="-122"/>
+                <a:cs typeface="Arial" pitchFamily="34" charset="-120"/>
+              </a:rPr>
+              <a:t>Software bus (SB)</a:t>
+            </a:r>
+            <a:endParaRPr lang="en-US" sz="1400" dirty="0"/>
+          </a:p>
+        </p:txBody>
+      </p:sp>
+      <p:sp>
+        <p:nvSpPr>
+          <p:cNvPr id="55" name="Role 2 cite"/>
+          <p:cNvSpPr/>
+          <p:nvPr/>
+        </p:nvSpPr>
+        <p:spPr>
+          <a:xfrm>
+            <a:off x="9943694" y="2350008"/>
+            <a:ext cx="266700" cy="155448"/>
+          </a:xfrm>
+          <a:prstGeom prst="rect">
+            <a:avLst/>
+          </a:prstGeom>
+          <a:noFill/>
+          <a:ln/>
+        </p:spPr>
+        <p:txBody>
+          <a:bodyPr wrap="square" lIns="0" tIns="0" rIns="0" bIns="0" rtlCol="0" anchor="t"/>
+          <a:lstStyle/>
+          <a:p>
+            <a:pPr algn="l" indent="0" marL="0">
+              <a:buNone/>
+            </a:pPr>
+            <a:r>
+              <a:rPr lang="en-US" sz="1000" dirty="0">
+                <a:solidFill>
+                  <a:srgbClr val="565E69"/>
+                </a:solidFill>
+                <a:latin typeface="Arial" pitchFamily="34" charset="0"/>
+                <a:ea typeface="Arial" pitchFamily="34" charset="-122"/>
+                <a:cs typeface="Arial" pitchFamily="34" charset="-120"/>
+              </a:rPr>
+              <a:t>p45</a:t>
+            </a:r>
+            <a:endParaRPr lang="en-US" sz="1000" dirty="0"/>
+          </a:p>
+        </p:txBody>
+      </p:sp>
+      <p:sp>
+        <p:nvSpPr>
+          <p:cNvPr id="56" name="Role 2 text"/>
+          <p:cNvSpPr/>
+          <p:nvPr/>
+        </p:nvSpPr>
+        <p:spPr>
+          <a:xfrm>
+            <a:off x="8247888" y="2532888"/>
+            <a:ext cx="3483864" cy="429768"/>
+          </a:xfrm>
+          <a:prstGeom prst="rect">
+            <a:avLst/>
+          </a:prstGeom>
+          <a:noFill/>
+          <a:ln/>
+        </p:spPr>
+        <p:txBody>
+          <a:bodyPr wrap="square" lIns="0" tIns="0" rIns="0" bIns="0" rtlCol="0" anchor="t"/>
+          <a:lstStyle/>
+          <a:p>
+            <a:pPr algn="l" indent="0" marL="0">
+              <a:buNone/>
+            </a:pPr>
+            <a:r>
+              <a:rPr lang="en-US" sz="1400" dirty="0">
+                <a:solidFill>
+                  <a:srgbClr val="1F2328"/>
+                </a:solidFill>
+                <a:latin typeface="Arial" pitchFamily="34" charset="0"/>
+                <a:ea typeface="Arial" pitchFamily="34" charset="-122"/>
+                <a:cs typeface="Arial" pitchFamily="34" charset="-120"/>
+              </a:rPr>
+              <a:t>“Provides an application publish/subscribe messaging service”</a:t>
+            </a:r>
+            <a:endParaRPr lang="en-US" sz="1400" dirty="0"/>
+          </a:p>
+        </p:txBody>
+      </p:sp>
+      <p:sp>
+        <p:nvSpPr>
+          <p:cNvPr id="57" name="Role badge 3"/>
+          <p:cNvSpPr/>
+          <p:nvPr/>
+        </p:nvSpPr>
+        <p:spPr>
+          <a:xfrm>
+            <a:off x="7882128" y="3127248"/>
+            <a:ext cx="256032" cy="256032"/>
+          </a:xfrm>
+          <a:prstGeom prst="ellipse">
+            <a:avLst/>
+          </a:prstGeom>
+          <a:solidFill>
+            <a:srgbClr val="1F2328"/>
+          </a:solidFill>
+          <a:ln/>
+        </p:spPr>
+        <p:txBody>
+          <a:bodyPr wrap="square" lIns="0" tIns="0" rIns="0" bIns="0" rtlCol="0" anchor="ctr"/>
+          <a:lstStyle/>
+          <a:p>
+            <a:pPr algn="ctr" indent="0" marL="0">
+              <a:buNone/>
+            </a:pPr>
+            <a:r>
+              <a:rPr lang="en-US" sz="1200" b="1" dirty="0">
+                <a:solidFill>
+                  <a:srgbClr val="FFFFFF"/>
+                </a:solidFill>
+                <a:latin typeface="Arial" pitchFamily="34" charset="0"/>
+                <a:ea typeface="Arial" pitchFamily="34" charset="-122"/>
+                <a:cs typeface="Arial" pitchFamily="34" charset="-120"/>
+              </a:rPr>
+              <a:t>3</a:t>
+            </a:r>
+            <a:endParaRPr lang="en-US" sz="1200" dirty="0"/>
+          </a:p>
+        </p:txBody>
+      </p:sp>
+      <p:sp>
+        <p:nvSpPr>
+          <p:cNvPr id="58" name="Role 3 name"/>
+          <p:cNvSpPr/>
+          <p:nvPr/>
+        </p:nvSpPr>
+        <p:spPr>
+          <a:xfrm>
+            <a:off x="8247888" y="3127248"/>
+            <a:ext cx="2356663" cy="219456"/>
+          </a:xfrm>
+          <a:prstGeom prst="rect">
+            <a:avLst/>
+          </a:prstGeom>
+          <a:noFill/>
+          <a:ln/>
+        </p:spPr>
+        <p:txBody>
+          <a:bodyPr wrap="square" lIns="0" tIns="0" rIns="0" bIns="0" rtlCol="0" anchor="t"/>
+          <a:lstStyle/>
+          <a:p>
+            <a:pPr algn="l" indent="0" marL="0">
+              <a:buNone/>
+            </a:pPr>
+            <a:r>
+              <a:rPr lang="en-US" sz="1400" b="1" dirty="0">
+                <a:solidFill>
+                  <a:srgbClr val="1F2328"/>
+                </a:solidFill>
+                <a:latin typeface="Arial" pitchFamily="34" charset="0"/>
+                <a:ea typeface="Arial" pitchFamily="34" charset="-122"/>
+                <a:cs typeface="Arial" pitchFamily="34" charset="-120"/>
+              </a:rPr>
+              <a:t>OSAL (OS Abstraction API)</a:t>
+            </a:r>
+            <a:endParaRPr lang="en-US" sz="1400" dirty="0"/>
+          </a:p>
+        </p:txBody>
+      </p:sp>
+      <p:sp>
+        <p:nvSpPr>
+          <p:cNvPr id="59" name="Role 3 cite"/>
+          <p:cNvSpPr/>
+          <p:nvPr/>
+        </p:nvSpPr>
+        <p:spPr>
+          <a:xfrm>
+            <a:off x="10714279" y="3172968"/>
+            <a:ext cx="979678" cy="155448"/>
+          </a:xfrm>
+          <a:prstGeom prst="rect">
+            <a:avLst/>
+          </a:prstGeom>
+          <a:noFill/>
+          <a:ln/>
+        </p:spPr>
+        <p:txBody>
+          <a:bodyPr wrap="square" lIns="0" tIns="0" rIns="0" bIns="0" rtlCol="0" anchor="t"/>
+          <a:lstStyle/>
+          <a:p>
+            <a:pPr algn="l" indent="0" marL="0">
+              <a:buNone/>
+            </a:pPr>
+            <a:r>
+              <a:rPr lang="en-US" sz="1000" dirty="0">
+                <a:solidFill>
+                  <a:srgbClr val="565E69"/>
+                </a:solidFill>
+                <a:latin typeface="Arial" pitchFamily="34" charset="0"/>
+                <a:ea typeface="Arial" pitchFamily="34" charset="-122"/>
+                <a:cs typeface="Arial" pitchFamily="34" charset="-120"/>
+              </a:rPr>
+              <a:t>p23, paraphrase</a:t>
+            </a:r>
+            <a:endParaRPr lang="en-US" sz="1000" dirty="0"/>
+          </a:p>
+        </p:txBody>
+      </p:sp>
+      <p:sp>
+        <p:nvSpPr>
+          <p:cNvPr id="60" name="Role 3 text"/>
+          <p:cNvSpPr/>
+          <p:nvPr/>
+        </p:nvSpPr>
+        <p:spPr>
+          <a:xfrm>
+            <a:off x="8247888" y="3355848"/>
+            <a:ext cx="3483864" cy="429768"/>
+          </a:xfrm>
+          <a:prstGeom prst="rect">
+            <a:avLst/>
+          </a:prstGeom>
+          <a:noFill/>
+          <a:ln/>
+        </p:spPr>
+        <p:txBody>
+          <a:bodyPr wrap="square" lIns="0" tIns="0" rIns="0" bIns="0" rtlCol="0" anchor="t"/>
+          <a:lstStyle/>
+          <a:p>
+            <a:pPr algn="l" indent="0" marL="0">
+              <a:buNone/>
+            </a:pPr>
+            <a:r>
+              <a:rPr lang="en-US" sz="1400" dirty="0">
+                <a:solidFill>
+                  <a:srgbClr val="1F2328"/>
+                </a:solidFill>
+                <a:latin typeface="Arial" pitchFamily="34" charset="0"/>
+                <a:ea typeface="Arial" pitchFamily="34" charset="-122"/>
+                <a:cs typeface="Arial" pitchFamily="34" charset="-120"/>
+              </a:rPr>
+              <a:t>One API to the cFE, whatever real-time OS runs underneath</a:t>
+            </a:r>
+            <a:endParaRPr lang="en-US" sz="1400" dirty="0"/>
+          </a:p>
+        </p:txBody>
+      </p:sp>
+      <p:sp>
+        <p:nvSpPr>
+          <p:cNvPr id="61" name="Role badge 4"/>
+          <p:cNvSpPr/>
+          <p:nvPr/>
+        </p:nvSpPr>
+        <p:spPr>
+          <a:xfrm>
+            <a:off x="7882128" y="3950208"/>
+            <a:ext cx="256032" cy="256032"/>
+          </a:xfrm>
+          <a:prstGeom prst="ellipse">
+            <a:avLst/>
+          </a:prstGeom>
+          <a:solidFill>
+            <a:srgbClr val="1F2328"/>
+          </a:solidFill>
+          <a:ln/>
+        </p:spPr>
+        <p:txBody>
+          <a:bodyPr wrap="square" lIns="0" tIns="0" rIns="0" bIns="0" rtlCol="0" anchor="ctr"/>
+          <a:lstStyle/>
+          <a:p>
+            <a:pPr algn="ctr" indent="0" marL="0">
+              <a:buNone/>
+            </a:pPr>
+            <a:r>
+              <a:rPr lang="en-US" sz="1200" b="1" dirty="0">
+                <a:solidFill>
+                  <a:srgbClr val="FFFFFF"/>
+                </a:solidFill>
+                <a:latin typeface="Arial" pitchFamily="34" charset="0"/>
+                <a:ea typeface="Arial" pitchFamily="34" charset="-122"/>
+                <a:cs typeface="Arial" pitchFamily="34" charset="-120"/>
+              </a:rPr>
+              <a:t>4</a:t>
+            </a:r>
+            <a:endParaRPr lang="en-US" sz="1200" dirty="0"/>
+          </a:p>
+        </p:txBody>
+      </p:sp>
+      <p:sp>
+        <p:nvSpPr>
+          <p:cNvPr id="62" name="Role 4 name"/>
+          <p:cNvSpPr/>
+          <p:nvPr/>
+        </p:nvSpPr>
+        <p:spPr>
+          <a:xfrm>
+            <a:off x="8247888" y="3950208"/>
+            <a:ext cx="1655597" cy="219456"/>
+          </a:xfrm>
+          <a:prstGeom prst="rect">
+            <a:avLst/>
+          </a:prstGeom>
+          <a:noFill/>
+          <a:ln/>
+        </p:spPr>
+        <p:txBody>
+          <a:bodyPr wrap="square" lIns="0" tIns="0" rIns="0" bIns="0" rtlCol="0" anchor="t"/>
+          <a:lstStyle/>
+          <a:p>
+            <a:pPr algn="l" indent="0" marL="0">
+              <a:buNone/>
+            </a:pPr>
+            <a:r>
+              <a:rPr lang="en-US" sz="1400" b="1" dirty="0">
+                <a:solidFill>
+                  <a:srgbClr val="1F2328"/>
+                </a:solidFill>
+                <a:latin typeface="Arial" pitchFamily="34" charset="0"/>
+                <a:ea typeface="Arial" pitchFamily="34" charset="-122"/>
+                <a:cs typeface="Arial" pitchFamily="34" charset="-120"/>
+              </a:rPr>
+              <a:t>PSP (cFE PSP API)</a:t>
+            </a:r>
+            <a:endParaRPr lang="en-US" sz="1400" dirty="0"/>
+          </a:p>
+        </p:txBody>
+      </p:sp>
+      <p:sp>
+        <p:nvSpPr>
+          <p:cNvPr id="63" name="Role 4 cite"/>
+          <p:cNvSpPr/>
+          <p:nvPr/>
+        </p:nvSpPr>
+        <p:spPr>
+          <a:xfrm>
+            <a:off x="10013213" y="3995928"/>
+            <a:ext cx="979678" cy="155448"/>
+          </a:xfrm>
+          <a:prstGeom prst="rect">
+            <a:avLst/>
+          </a:prstGeom>
+          <a:noFill/>
+          <a:ln/>
+        </p:spPr>
+        <p:txBody>
+          <a:bodyPr wrap="square" lIns="0" tIns="0" rIns="0" bIns="0" rtlCol="0" anchor="t"/>
+          <a:lstStyle/>
+          <a:p>
+            <a:pPr algn="l" indent="0" marL="0">
+              <a:buNone/>
+            </a:pPr>
+            <a:r>
+              <a:rPr lang="en-US" sz="1000" dirty="0">
+                <a:solidFill>
+                  <a:srgbClr val="565E69"/>
+                </a:solidFill>
+                <a:latin typeface="Arial" pitchFamily="34" charset="0"/>
+                <a:ea typeface="Arial" pitchFamily="34" charset="-122"/>
+                <a:cs typeface="Arial" pitchFamily="34" charset="-120"/>
+              </a:rPr>
+              <a:t>p24, paraphrase</a:t>
+            </a:r>
+            <a:endParaRPr lang="en-US" sz="1000" dirty="0"/>
+          </a:p>
+        </p:txBody>
+      </p:sp>
+      <p:sp>
+        <p:nvSpPr>
+          <p:cNvPr id="64" name="Role 4 text"/>
+          <p:cNvSpPr/>
+          <p:nvPr/>
+        </p:nvSpPr>
+        <p:spPr>
+          <a:xfrm>
+            <a:off x="8247888" y="4178808"/>
+            <a:ext cx="3483864" cy="429768"/>
+          </a:xfrm>
+          <a:prstGeom prst="rect">
+            <a:avLst/>
+          </a:prstGeom>
+          <a:noFill/>
+          <a:ln/>
+        </p:spPr>
+        <p:txBody>
+          <a:bodyPr wrap="square" lIns="0" tIns="0" rIns="0" bIns="0" rtlCol="0" anchor="t"/>
+          <a:lstStyle/>
+          <a:p>
+            <a:pPr algn="l" indent="0" marL="0">
+              <a:buNone/>
+            </a:pPr>
+            <a:r>
+              <a:rPr lang="en-US" sz="1400" dirty="0">
+                <a:solidFill>
+                  <a:srgbClr val="1F2328"/>
+                </a:solidFill>
+                <a:latin typeface="Arial" pitchFamily="34" charset="0"/>
+                <a:ea typeface="Arial" pitchFamily="34" charset="-122"/>
+                <a:cs typeface="Arial" pitchFamily="34" charset="-120"/>
+              </a:rPr>
+              <a:t>One API to the avionics hardware and board support package</a:t>
+            </a:r>
+            <a:endParaRPr lang="en-US" sz="1400" dirty="0"/>
+          </a:p>
+        </p:txBody>
+      </p:sp>
+      <p:sp>
+        <p:nvSpPr>
+          <p:cNvPr id="65" name="Legend title"/>
+          <p:cNvSpPr/>
+          <p:nvPr/>
+        </p:nvSpPr>
+        <p:spPr>
+          <a:xfrm>
+            <a:off x="7882128" y="4846320"/>
+            <a:ext cx="3849624" cy="182880"/>
+          </a:xfrm>
+          <a:prstGeom prst="rect">
+            <a:avLst/>
+          </a:prstGeom>
+          <a:noFill/>
+          <a:ln/>
+        </p:spPr>
+        <p:txBody>
+          <a:bodyPr wrap="square" lIns="0" tIns="0" rIns="0" bIns="0" rtlCol="0" anchor="t"/>
+          <a:lstStyle/>
+          <a:p>
+            <a:pPr algn="l" indent="0" marL="0">
+              <a:buNone/>
+            </a:pPr>
+            <a:r>
+              <a:rPr lang="en-US" sz="1100" b="1" dirty="0">
+                <a:solidFill>
+                  <a:srgbClr val="1F2328"/>
+                </a:solidFill>
+                <a:latin typeface="Arial" pitchFamily="34" charset="0"/>
+                <a:ea typeface="Arial" pitchFamily="34" charset="-122"/>
+                <a:cs typeface="Arial" pitchFamily="34" charset="-120"/>
+              </a:rPr>
+              <a:t>Status as of August 2015</a:t>
+            </a:r>
+            <a:endParaRPr lang="en-US" sz="1100" dirty="0"/>
+          </a:p>
+        </p:txBody>
+      </p:sp>
+      <p:sp>
+        <p:nvSpPr>
+          <p:cNvPr id="66" name="Legend swatch Open source, NASA maintained"/>
+          <p:cNvSpPr/>
+          <p:nvPr/>
+        </p:nvSpPr>
+        <p:spPr>
+          <a:xfrm>
+            <a:off x="7882128" y="5065776"/>
+            <a:ext cx="274320" cy="137160"/>
+          </a:xfrm>
+          <a:prstGeom prst="rect">
+            <a:avLst/>
+          </a:prstGeom>
+          <a:solidFill>
+            <a:srgbClr val="DCE6F0"/>
+          </a:solidFill>
+          <a:ln w="12700">
+            <a:solidFill>
+              <a:srgbClr val="2F5D8A"/>
+            </a:solidFill>
+            <a:prstDash val="solid"/>
+          </a:ln>
+        </p:spPr>
+      </p:sp>
+      <p:sp>
+        <p:nvSpPr>
+          <p:cNvPr id="67" name="Legend Open source, NASA maintained"/>
+          <p:cNvSpPr/>
+          <p:nvPr/>
+        </p:nvSpPr>
+        <p:spPr>
+          <a:xfrm>
+            <a:off x="8229600" y="5038344"/>
+            <a:ext cx="1828800" cy="182880"/>
+          </a:xfrm>
+          <a:prstGeom prst="rect">
+            <a:avLst/>
+          </a:prstGeom>
+          <a:noFill/>
+          <a:ln/>
+        </p:spPr>
+        <p:txBody>
+          <a:bodyPr wrap="square" lIns="0" tIns="0" rIns="0" bIns="0" rtlCol="0" anchor="ctr"/>
+          <a:lstStyle/>
+          <a:p>
+            <a:pPr algn="l" indent="0" marL="0">
+              <a:buNone/>
+            </a:pPr>
+            <a:r>
+              <a:rPr lang="en-US" sz="1000" dirty="0">
+                <a:solidFill>
+                  <a:srgbClr val="1F2328"/>
+                </a:solidFill>
+                <a:latin typeface="Arial" pitchFamily="34" charset="0"/>
+                <a:ea typeface="Arial" pitchFamily="34" charset="-122"/>
+                <a:cs typeface="Arial" pitchFamily="34" charset="-120"/>
+              </a:rPr>
+              <a:t>Open source, NASA maintained</a:t>
+            </a:r>
+            <a:endParaRPr lang="en-US" sz="1000" dirty="0"/>
+          </a:p>
+        </p:txBody>
+      </p:sp>
+      <p:sp>
+        <p:nvSpPr>
+          <p:cNvPr id="68" name="Legend swatch Mission developed"/>
+          <p:cNvSpPr/>
+          <p:nvPr/>
+        </p:nvSpPr>
+        <p:spPr>
+          <a:xfrm>
+            <a:off x="10094976" y="5065776"/>
+            <a:ext cx="274320" cy="137160"/>
+          </a:xfrm>
+          <a:prstGeom prst="rect">
+            <a:avLst/>
+          </a:prstGeom>
+          <a:solidFill>
+            <a:srgbClr val="FBE4D2"/>
+          </a:solidFill>
+          <a:ln w="15875">
+            <a:solidFill>
+              <a:srgbClr val="B85F1E"/>
+            </a:solidFill>
+            <a:prstDash val="solid"/>
+          </a:ln>
+        </p:spPr>
+      </p:sp>
+      <p:sp>
+        <p:nvSpPr>
+          <p:cNvPr id="69" name="Legend Mission developed"/>
+          <p:cNvSpPr/>
+          <p:nvPr/>
+        </p:nvSpPr>
+        <p:spPr>
+          <a:xfrm>
+            <a:off x="10442448" y="5038344"/>
+            <a:ext cx="1170432" cy="182880"/>
+          </a:xfrm>
+          <a:prstGeom prst="rect">
+            <a:avLst/>
+          </a:prstGeom>
+          <a:noFill/>
+          <a:ln/>
+        </p:spPr>
+        <p:txBody>
+          <a:bodyPr wrap="square" lIns="0" tIns="0" rIns="0" bIns="0" rtlCol="0" anchor="ctr"/>
+          <a:lstStyle/>
+          <a:p>
+            <a:pPr algn="l" indent="0" marL="0">
+              <a:buNone/>
+            </a:pPr>
+            <a:r>
+              <a:rPr lang="en-US" sz="1000" dirty="0">
+                <a:solidFill>
+                  <a:srgbClr val="1F2328"/>
+                </a:solidFill>
+                <a:latin typeface="Arial" pitchFamily="34" charset="0"/>
+                <a:ea typeface="Arial" pitchFamily="34" charset="-122"/>
+                <a:cs typeface="Arial" pitchFamily="34" charset="-120"/>
+              </a:rPr>
+              <a:t>Mission developed</a:t>
+            </a:r>
+            <a:endParaRPr lang="en-US" sz="1000" dirty="0"/>
+          </a:p>
+        </p:txBody>
+      </p:sp>
+      <p:sp>
+        <p:nvSpPr>
+          <p:cNvPr id="70" name="Legend swatch In development"/>
+          <p:cNvSpPr/>
+          <p:nvPr/>
+        </p:nvSpPr>
+        <p:spPr>
+          <a:xfrm>
+            <a:off x="7882128" y="5248656"/>
+            <a:ext cx="274320" cy="137160"/>
+          </a:xfrm>
+          <a:prstGeom prst="rect">
+            <a:avLst/>
+          </a:prstGeom>
+          <a:solidFill>
+            <a:srgbClr val="FFFFFF"/>
+          </a:solidFill>
+          <a:ln w="15875">
+            <a:solidFill>
+              <a:srgbClr val="2F5D8A"/>
+            </a:solidFill>
+            <a:prstDash val="dash"/>
+          </a:ln>
+        </p:spPr>
+      </p:sp>
+      <p:sp>
+        <p:nvSpPr>
+          <p:cNvPr id="71" name="Legend In development"/>
+          <p:cNvSpPr/>
+          <p:nvPr/>
+        </p:nvSpPr>
+        <p:spPr>
+          <a:xfrm>
+            <a:off x="8229600" y="5221224"/>
+            <a:ext cx="1828800" cy="182880"/>
+          </a:xfrm>
+          <a:prstGeom prst="rect">
+            <a:avLst/>
+          </a:prstGeom>
+          <a:noFill/>
+          <a:ln/>
+        </p:spPr>
+        <p:txBody>
+          <a:bodyPr wrap="square" lIns="0" tIns="0" rIns="0" bIns="0" rtlCol="0" anchor="ctr"/>
+          <a:lstStyle/>
+          <a:p>
+            <a:pPr algn="l" indent="0" marL="0">
+              <a:buNone/>
+            </a:pPr>
+            <a:r>
+              <a:rPr lang="en-US" sz="1000" dirty="0">
+                <a:solidFill>
+                  <a:srgbClr val="1F2328"/>
+                </a:solidFill>
+                <a:latin typeface="Arial" pitchFamily="34" charset="0"/>
+                <a:ea typeface="Arial" pitchFamily="34" charset="-122"/>
+                <a:cs typeface="Arial" pitchFamily="34" charset="-120"/>
+              </a:rPr>
+              <a:t>In development</a:t>
+            </a:r>
+            <a:endParaRPr lang="en-US" sz="1000" dirty="0"/>
+          </a:p>
+        </p:txBody>
+      </p:sp>
+      <p:sp>
+        <p:nvSpPr>
+          <p:cNvPr id="72" name="Legend swatch Third party"/>
+          <p:cNvSpPr/>
+          <p:nvPr/>
+        </p:nvSpPr>
+        <p:spPr>
+          <a:xfrm>
+            <a:off x="10094976" y="5248656"/>
+            <a:ext cx="274320" cy="137160"/>
+          </a:xfrm>
+          <a:prstGeom prst="rect">
+            <a:avLst/>
+          </a:prstGeom>
+          <a:solidFill>
+            <a:srgbClr val="E4E7EB"/>
+          </a:solidFill>
+          <a:ln w="12700">
+            <a:solidFill>
+              <a:srgbClr val="7C8591"/>
+            </a:solidFill>
+            <a:prstDash val="solid"/>
+          </a:ln>
+        </p:spPr>
+      </p:sp>
+      <p:sp>
+        <p:nvSpPr>
+          <p:cNvPr id="73" name="Legend Third party"/>
+          <p:cNvSpPr/>
+          <p:nvPr/>
+        </p:nvSpPr>
+        <p:spPr>
+          <a:xfrm>
+            <a:off x="10442448" y="5221224"/>
+            <a:ext cx="1170432" cy="182880"/>
+          </a:xfrm>
+          <a:prstGeom prst="rect">
+            <a:avLst/>
+          </a:prstGeom>
+          <a:noFill/>
+          <a:ln/>
+        </p:spPr>
+        <p:txBody>
+          <a:bodyPr wrap="square" lIns="0" tIns="0" rIns="0" bIns="0" rtlCol="0" anchor="ctr"/>
+          <a:lstStyle/>
+          <a:p>
+            <a:pPr algn="l" indent="0" marL="0">
+              <a:buNone/>
+            </a:pPr>
+            <a:r>
+              <a:rPr lang="en-US" sz="1000" dirty="0">
+                <a:solidFill>
+                  <a:srgbClr val="1F2328"/>
+                </a:solidFill>
+                <a:latin typeface="Arial" pitchFamily="34" charset="0"/>
+                <a:ea typeface="Arial" pitchFamily="34" charset="-122"/>
+                <a:cs typeface="Arial" pitchFamily="34" charset="-120"/>
+              </a:rPr>
+              <a:t>Third party</a:t>
+            </a:r>
+            <a:endParaRPr lang="en-US" sz="1000" dirty="0"/>
+          </a:p>
+        </p:txBody>
+      </p:sp>
+      <p:sp>
+        <p:nvSpPr>
+          <p:cNvPr id="74" name="Legend swatch No status color in source"/>
+          <p:cNvSpPr/>
+          <p:nvPr/>
+        </p:nvSpPr>
+        <p:spPr>
+          <a:xfrm>
+            <a:off x="7882128" y="5431536"/>
+            <a:ext cx="274320" cy="137160"/>
+          </a:xfrm>
+          <a:prstGeom prst="rect">
+            <a:avLst/>
+          </a:prstGeom>
+          <a:solidFill>
+            <a:srgbClr val="FFFFFF"/>
+          </a:solidFill>
+          <a:ln w="9525">
+            <a:solidFill>
+              <a:srgbClr val="7C8591"/>
+            </a:solidFill>
+            <a:prstDash val="solid"/>
+          </a:ln>
+        </p:spPr>
+      </p:sp>
+      <p:sp>
+        <p:nvSpPr>
+          <p:cNvPr id="75" name="Legend No status color in source"/>
+          <p:cNvSpPr/>
+          <p:nvPr/>
+        </p:nvSpPr>
+        <p:spPr>
+          <a:xfrm>
+            <a:off x="8229600" y="5404104"/>
+            <a:ext cx="1828800" cy="182880"/>
+          </a:xfrm>
+          <a:prstGeom prst="rect">
+            <a:avLst/>
+          </a:prstGeom>
+          <a:noFill/>
+          <a:ln/>
+        </p:spPr>
+        <p:txBody>
+          <a:bodyPr wrap="square" lIns="0" tIns="0" rIns="0" bIns="0" rtlCol="0" anchor="ctr"/>
+          <a:lstStyle/>
+          <a:p>
+            <a:pPr algn="l" indent="0" marL="0">
+              <a:buNone/>
+            </a:pPr>
+            <a:r>
+              <a:rPr lang="en-US" sz="1000" dirty="0">
+                <a:solidFill>
+                  <a:srgbClr val="1F2328"/>
+                </a:solidFill>
+                <a:latin typeface="Arial" pitchFamily="34" charset="0"/>
+                <a:ea typeface="Arial" pitchFamily="34" charset="-122"/>
+                <a:cs typeface="Arial" pitchFamily="34" charset="-120"/>
+              </a:rPr>
+              <a:t>No status color in source</a:t>
+            </a:r>
+            <a:endParaRPr lang="en-US" sz="1000" dirty="0"/>
+          </a:p>
+        </p:txBody>
+      </p:sp>
+      <p:sp>
+        <p:nvSpPr>
+          <p:cNvPr id="76" name="Legend swatch Layer API"/>
+          <p:cNvSpPr/>
+          <p:nvPr/>
+        </p:nvSpPr>
+        <p:spPr>
+          <a:xfrm>
+            <a:off x="10094976" y="5431536"/>
+            <a:ext cx="274320" cy="137160"/>
+          </a:xfrm>
+          <a:prstGeom prst="rect">
+            <a:avLst/>
+          </a:prstGeom>
+          <a:solidFill>
+            <a:srgbClr val="2F5D8A"/>
+          </a:solidFill>
+          <a:ln/>
+        </p:spPr>
+      </p:sp>
+      <p:sp>
+        <p:nvSpPr>
+          <p:cNvPr id="77" name="Legend Layer API"/>
+          <p:cNvSpPr/>
+          <p:nvPr/>
+        </p:nvSpPr>
+        <p:spPr>
+          <a:xfrm>
+            <a:off x="10442448" y="5404104"/>
+            <a:ext cx="1170432" cy="182880"/>
+          </a:xfrm>
+          <a:prstGeom prst="rect">
+            <a:avLst/>
+          </a:prstGeom>
+          <a:noFill/>
+          <a:ln/>
+        </p:spPr>
+        <p:txBody>
+          <a:bodyPr wrap="square" lIns="0" tIns="0" rIns="0" bIns="0" rtlCol="0" anchor="ctr"/>
+          <a:lstStyle/>
+          <a:p>
+            <a:pPr algn="l" indent="0" marL="0">
+              <a:buNone/>
+            </a:pPr>
+            <a:r>
+              <a:rPr lang="en-US" sz="1000" dirty="0">
+                <a:solidFill>
+                  <a:srgbClr val="1F2328"/>
+                </a:solidFill>
+                <a:latin typeface="Arial" pitchFamily="34" charset="0"/>
+                <a:ea typeface="Arial" pitchFamily="34" charset="-122"/>
+                <a:cs typeface="Arial" pitchFamily="34" charset="-120"/>
+              </a:rPr>
+              <a:t>Layer API</a:t>
+            </a:r>
+            <a:endParaRPr lang="en-US" sz="1000" dirty="0"/>
+          </a:p>
+        </p:txBody>
+      </p:sp>
+      <p:sp>
+        <p:nvSpPr>
+          <p:cNvPr id="78" name="Sources"/>
+          <p:cNvSpPr/>
+          <p:nvPr/>
+        </p:nvSpPr>
+        <p:spPr>
+          <a:xfrm>
+            <a:off x="457200" y="5687568"/>
+            <a:ext cx="11274552" cy="329184"/>
+          </a:xfrm>
+          <a:prstGeom prst="rect">
+            <a:avLst/>
+          </a:prstGeom>
+          <a:noFill/>
+          <a:ln/>
+        </p:spPr>
+        <p:txBody>
+          <a:bodyPr wrap="square" lIns="0" tIns="0" rIns="0" bIns="0" rtlCol="0" anchor="t"/>
+          <a:lstStyle/>
+          <a:p>
+            <a:pPr algn="l" indent="0" marL="0">
+              <a:buNone/>
+            </a:pPr>
+            <a:r>
+              <a:rPr lang="en-US" sz="1000" dirty="0">
+                <a:solidFill>
+                  <a:srgbClr val="565E69"/>
+                </a:solidFill>
+                <a:latin typeface="Arial" pitchFamily="34" charset="0"/>
+                <a:ea typeface="Arial" pitchFamily="34" charset="-122"/>
+                <a:cs typeface="Arial" pitchFamily="34" charset="-120"/>
+              </a:rPr>
+              <a:t>Source: diagram rebuilt from McComas et al., NASA Goddard, Aug. 2015, NTRS 20150018075, p8. Service acronyms and order: 2021 memo, printed p45 (the 2015 deck lists the same five services on p9). Roles: NASA/TM-20205000691/REV 1, Jan. 2021, NTRS 20205011588, printed page on each heading. Dark bars: each layer’s standard API (2023 overview, NTRS 20230002444, slide 8).</a:t>
+            </a:r>
+            <a:endParaRPr lang="en-US" sz="1000" dirty="0"/>
+          </a:p>
+        </p:txBody>
+      </p:sp>
+      <p:sp>
+        <p:nvSpPr>
+          <p:cNvPr id="79" name="Footer"/>
+          <p:cNvSpPr/>
+          <p:nvPr/>
+        </p:nvSpPr>
+        <p:spPr>
+          <a:xfrm>
+            <a:off x="457200" y="6144768"/>
+            <a:ext cx="11274552" cy="201168"/>
+          </a:xfrm>
+          <a:prstGeom prst="rect">
+            <a:avLst/>
+          </a:prstGeom>
+          <a:noFill/>
+          <a:ln/>
+        </p:spPr>
+        <p:txBody>
+          <a:bodyPr wrap="square" lIns="0" tIns="0" rIns="0" bIns="0" rtlCol="0" anchor="t"/>
+          <a:lstStyle/>
+          <a:p>
+            <a:pPr algn="l" indent="0" marL="0">
+              <a:buNone/>
+            </a:pPr>
+            <a:r>
+              <a:rPr lang="en-US" sz="1000" dirty="0">
+                <a:solidFill>
+                  <a:srgbClr val="565E69"/>
+                </a:solidFill>
+                <a:latin typeface="Arial" pitchFamily="34" charset="0"/>
+                <a:ea typeface="Arial" pitchFamily="34" charset="-122"/>
+                <a:cs typeface="Arial" pitchFamily="34" charset="-120"/>
+              </a:rPr>
+              <a:t>Portfolio reconstruction of a public NASA slide. Not a NASA document.</a:t>
+            </a:r>
+            <a:endParaRPr lang="en-US" sz="1000" dirty="0"/>
           </a:p>
         </p:txBody>
       </p:sp>

</xml_diff>